<commit_message>
docs: add Denis Frolov and formalize competition presentation
</commit_message>
<xml_diff>
--- a/submission/HSE_AI_Video.pptx
+++ b/submission/HSE_AI_Video.pptx
@@ -2,36 +2,36 @@
 <file path=ppt/presentation.xml><?xml version="1.0" encoding="utf-8"?>
 <p:presentation xmlns:p="http://schemas.openxmlformats.org/presentationml/2006/main" embedTrueTypeFonts="1" saveSubsetFonts="0">
   <p:sldMasterIdLst>
-    <p:sldMasterId xmlns:r="http://schemas.openxmlformats.org/officeDocument/2006/relationships" id="2147483648" r:id="R139a002442d842ea"/>
+    <p:sldMasterId xmlns:r="http://schemas.openxmlformats.org/officeDocument/2006/relationships" id="2147483648" r:id="Rf1c325f6164448d4"/>
   </p:sldMasterIdLst>
   <p:notesMasterIdLst>
-    <p:notesMasterId xmlns:r="http://schemas.openxmlformats.org/officeDocument/2006/relationships" r:id="Rf2079ae21a7d4bf7"/>
+    <p:notesMasterId xmlns:r="http://schemas.openxmlformats.org/officeDocument/2006/relationships" r:id="Rb85b8507f79c4f11"/>
   </p:notesMasterIdLst>
   <p:sldIdLst>
-    <p:sldId xmlns:r="http://schemas.openxmlformats.org/officeDocument/2006/relationships" id="256" r:id="R6f09f7a6413d43e6"/>
-    <p:sldId xmlns:r="http://schemas.openxmlformats.org/officeDocument/2006/relationships" id="257" r:id="R8f7f85151c234e21"/>
-    <p:sldId xmlns:r="http://schemas.openxmlformats.org/officeDocument/2006/relationships" id="258" r:id="Rae5f38cdb9044c56"/>
-    <p:sldId xmlns:r="http://schemas.openxmlformats.org/officeDocument/2006/relationships" id="259" r:id="R6d8d805c8ac646f0"/>
-    <p:sldId xmlns:r="http://schemas.openxmlformats.org/officeDocument/2006/relationships" id="260" r:id="R955a32cd8d994b5b"/>
-    <p:sldId xmlns:r="http://schemas.openxmlformats.org/officeDocument/2006/relationships" id="261" r:id="Rb43fc53c326a408a"/>
-    <p:sldId xmlns:r="http://schemas.openxmlformats.org/officeDocument/2006/relationships" id="262" r:id="Re9518dd3971f46c2"/>
-    <p:sldId xmlns:r="http://schemas.openxmlformats.org/officeDocument/2006/relationships" id="263" r:id="Rfd7e957a57e34b7e"/>
-    <p:sldId xmlns:r="http://schemas.openxmlformats.org/officeDocument/2006/relationships" id="264" r:id="R7b369b2a8c1f46ae"/>
-    <p:sldId xmlns:r="http://schemas.openxmlformats.org/officeDocument/2006/relationships" id="265" r:id="R4e52745c7f6f4e30"/>
-    <p:sldId xmlns:r="http://schemas.openxmlformats.org/officeDocument/2006/relationships" id="266" r:id="R93e58f94bcff4f00"/>
-    <p:sldId xmlns:r="http://schemas.openxmlformats.org/officeDocument/2006/relationships" id="267" r:id="R9bb96d05ccca4e02"/>
-    <p:sldId xmlns:r="http://schemas.openxmlformats.org/officeDocument/2006/relationships" id="268" r:id="Rbb19e3b1209d4de6"/>
-    <p:sldId xmlns:r="http://schemas.openxmlformats.org/officeDocument/2006/relationships" id="269" r:id="Rc72d0ba895844095"/>
+    <p:sldId xmlns:r="http://schemas.openxmlformats.org/officeDocument/2006/relationships" id="256" r:id="Ra90988ba8f3748a0"/>
+    <p:sldId xmlns:r="http://schemas.openxmlformats.org/officeDocument/2006/relationships" id="257" r:id="R8842686f912f4ef7"/>
+    <p:sldId xmlns:r="http://schemas.openxmlformats.org/officeDocument/2006/relationships" id="258" r:id="Re29e8c7e8c4a47cf"/>
+    <p:sldId xmlns:r="http://schemas.openxmlformats.org/officeDocument/2006/relationships" id="259" r:id="R870c0aed39e848f7"/>
+    <p:sldId xmlns:r="http://schemas.openxmlformats.org/officeDocument/2006/relationships" id="260" r:id="R5aa01d95653049c7"/>
+    <p:sldId xmlns:r="http://schemas.openxmlformats.org/officeDocument/2006/relationships" id="261" r:id="Rf0e5011da339423e"/>
+    <p:sldId xmlns:r="http://schemas.openxmlformats.org/officeDocument/2006/relationships" id="262" r:id="Re58ece171c044eed"/>
+    <p:sldId xmlns:r="http://schemas.openxmlformats.org/officeDocument/2006/relationships" id="263" r:id="R1ec8179ccb0641fd"/>
+    <p:sldId xmlns:r="http://schemas.openxmlformats.org/officeDocument/2006/relationships" id="264" r:id="Re14da47d5e664917"/>
+    <p:sldId xmlns:r="http://schemas.openxmlformats.org/officeDocument/2006/relationships" id="265" r:id="R7e2671ad9c5e418d"/>
+    <p:sldId xmlns:r="http://schemas.openxmlformats.org/officeDocument/2006/relationships" id="266" r:id="Rc6bef24b61be441d"/>
+    <p:sldId xmlns:r="http://schemas.openxmlformats.org/officeDocument/2006/relationships" id="267" r:id="Rc1391b1f6a06417a"/>
+    <p:sldId xmlns:r="http://schemas.openxmlformats.org/officeDocument/2006/relationships" id="268" r:id="Rfe3720068c174af6"/>
+    <p:sldId xmlns:r="http://schemas.openxmlformats.org/officeDocument/2006/relationships" id="269" r:id="R450ff7e0c18d4ab5"/>
   </p:sldIdLst>
   <p:sldSz cx="12192000" cy="6858000"/>
   <p:notesSz cx="6858000" cy="9144000"/>
   <p:embeddedFontLst>
     <p:embeddedFont>
       <p:font typeface="PF Centro Sans Pro"/>
-      <p:regular xmlns:r="http://schemas.openxmlformats.org/officeDocument/2006/relationships" r:id="Rc6d8f13fc08b4728"/>
-      <p:bold xmlns:r="http://schemas.openxmlformats.org/officeDocument/2006/relationships" r:id="R111a6a41b58449f4"/>
-      <p:italic xmlns:r="http://schemas.openxmlformats.org/officeDocument/2006/relationships" r:id="Rb15e93e0f9494ff0"/>
-      <p:boldItalic xmlns:r="http://schemas.openxmlformats.org/officeDocument/2006/relationships" r:id="R45d8de8f60534305"/>
+      <p:regular xmlns:r="http://schemas.openxmlformats.org/officeDocument/2006/relationships" r:id="R6ddb875ef6664397"/>
+      <p:bold xmlns:r="http://schemas.openxmlformats.org/officeDocument/2006/relationships" r:id="Rbc9089779b3e4736"/>
+      <p:italic xmlns:r="http://schemas.openxmlformats.org/officeDocument/2006/relationships" r:id="R3f512aa40c594bfa"/>
+      <p:boldItalic xmlns:r="http://schemas.openxmlformats.org/officeDocument/2006/relationships" r:id="R44adb640d54544f1"/>
     </p:embeddedFont>
   </p:embeddedFontLst>
 </p:presentation>
@@ -1452,7 +1452,7 @@
           <p:cNvPr id="2" name="Title 1">
             <a:extLst xmlns:a="http://schemas.openxmlformats.org/drawingml/2006/main">
               <a:ext uri="{FF2B5EF4-FFF2-40B4-BE49-F238E27FC236}">
-                <a16:creationId xmlns:a16="http://schemas.microsoft.com/office/drawing/2014/main" id="{63C7017D-F9FA-4245-8469-FC8F337E8B0A}"/>
+                <a16:creationId xmlns:a16="http://schemas.microsoft.com/office/drawing/2014/main" id="{C37A78C9-49E7-400D-B7FE-FCAC7E5D453E}"/>
               </a:ext>
             </a:extLst>
           </p:cNvPr>
@@ -1490,7 +1490,7 @@
           <p:cNvPr id="3" name="Subtitle 2">
             <a:extLst xmlns:a="http://schemas.openxmlformats.org/drawingml/2006/main">
               <a:ext uri="{FF2B5EF4-FFF2-40B4-BE49-F238E27FC236}">
-                <a16:creationId xmlns:a16="http://schemas.microsoft.com/office/drawing/2014/main" id="{E1FAA04C-18EF-4DAE-BEA1-6EB7E65BDB5B}"/>
+                <a16:creationId xmlns:a16="http://schemas.microsoft.com/office/drawing/2014/main" id="{9BB456D2-2C65-4510-9219-D5CED78ABBCF}"/>
               </a:ext>
             </a:extLst>
           </p:cNvPr>
@@ -1560,7 +1560,7 @@
           <p:cNvPr id="4" name="Date Placeholder 3">
             <a:extLst xmlns:a="http://schemas.openxmlformats.org/drawingml/2006/main">
               <a:ext uri="{FF2B5EF4-FFF2-40B4-BE49-F238E27FC236}">
-                <a16:creationId xmlns:a16="http://schemas.microsoft.com/office/drawing/2014/main" id="{8F05EA2E-D83B-4A0A-A51D-C180D1641A4B}"/>
+                <a16:creationId xmlns:a16="http://schemas.microsoft.com/office/drawing/2014/main" id="{E7390CF4-8925-44DE-B842-B8E899E64884}"/>
               </a:ext>
             </a:extLst>
           </p:cNvPr>
@@ -1588,7 +1588,7 @@
           <p:cNvPr id="5" name="Footer Placeholder 4">
             <a:extLst xmlns:a="http://schemas.openxmlformats.org/drawingml/2006/main">
               <a:ext uri="{FF2B5EF4-FFF2-40B4-BE49-F238E27FC236}">
-                <a16:creationId xmlns:a16="http://schemas.microsoft.com/office/drawing/2014/main" id="{257CDD2D-1967-4AE0-87BB-D2DB7AFDC4B2}"/>
+                <a16:creationId xmlns:a16="http://schemas.microsoft.com/office/drawing/2014/main" id="{9D6688E0-F8DA-4C7C-A99A-A4F36A1F9313}"/>
               </a:ext>
             </a:extLst>
           </p:cNvPr>
@@ -1613,7 +1613,7 @@
           <p:cNvPr id="6" name="Slide Number Placeholder 5">
             <a:extLst xmlns:a="http://schemas.openxmlformats.org/drawingml/2006/main">
               <a:ext uri="{FF2B5EF4-FFF2-40B4-BE49-F238E27FC236}">
-                <a16:creationId xmlns:a16="http://schemas.microsoft.com/office/drawing/2014/main" id="{16543CA1-10B7-4E02-8389-9F2149556B0D}"/>
+                <a16:creationId xmlns:a16="http://schemas.microsoft.com/office/drawing/2014/main" id="{75E07B8F-F30D-4BF1-ADF6-8CFC7861882B}"/>
               </a:ext>
             </a:extLst>
           </p:cNvPr>
@@ -1658,7 +1658,7 @@
           <p:cNvPr id="2" name="Title 1">
             <a:extLst xmlns:a="http://schemas.openxmlformats.org/drawingml/2006/main">
               <a:ext uri="{FF2B5EF4-FFF2-40B4-BE49-F238E27FC236}">
-                <a16:creationId xmlns:a16="http://schemas.microsoft.com/office/drawing/2014/main" id="{4EF3F697-1D8C-4BDD-B6FF-71B586C306FE}"/>
+                <a16:creationId xmlns:a16="http://schemas.microsoft.com/office/drawing/2014/main" id="{B0FDF7E2-EE14-4A47-953F-FAB405F5F3E6}"/>
               </a:ext>
             </a:extLst>
           </p:cNvPr>
@@ -1686,7 +1686,7 @@
           <p:cNvPr id="3" name="Vertical Text Placeholder 2">
             <a:extLst xmlns:a="http://schemas.openxmlformats.org/drawingml/2006/main">
               <a:ext uri="{FF2B5EF4-FFF2-40B4-BE49-F238E27FC236}">
-                <a16:creationId xmlns:a16="http://schemas.microsoft.com/office/drawing/2014/main" id="{2DFBC08F-5B7C-4990-B4C0-609F79D4A8CB}"/>
+                <a16:creationId xmlns:a16="http://schemas.microsoft.com/office/drawing/2014/main" id="{5AF4EBC4-51D9-4187-931C-9D278ACABAA8}"/>
               </a:ext>
             </a:extLst>
           </p:cNvPr>
@@ -1749,7 +1749,7 @@
           <p:cNvPr id="4" name="Date Placeholder 3">
             <a:extLst xmlns:a="http://schemas.openxmlformats.org/drawingml/2006/main">
               <a:ext uri="{FF2B5EF4-FFF2-40B4-BE49-F238E27FC236}">
-                <a16:creationId xmlns:a16="http://schemas.microsoft.com/office/drawing/2014/main" id="{F1927D51-2F35-4F0A-B87A-976F42D74C07}"/>
+                <a16:creationId xmlns:a16="http://schemas.microsoft.com/office/drawing/2014/main" id="{A6CEE8AD-82FB-4B8E-80C9-8B9511F17ACB}"/>
               </a:ext>
             </a:extLst>
           </p:cNvPr>
@@ -1777,7 +1777,7 @@
           <p:cNvPr id="5" name="Footer Placeholder 4">
             <a:extLst xmlns:a="http://schemas.openxmlformats.org/drawingml/2006/main">
               <a:ext uri="{FF2B5EF4-FFF2-40B4-BE49-F238E27FC236}">
-                <a16:creationId xmlns:a16="http://schemas.microsoft.com/office/drawing/2014/main" id="{67B314CE-EE7A-49A8-B3C7-C77319DCAA82}"/>
+                <a16:creationId xmlns:a16="http://schemas.microsoft.com/office/drawing/2014/main" id="{76AD075A-312B-4671-B965-22E075D33D15}"/>
               </a:ext>
             </a:extLst>
           </p:cNvPr>
@@ -1802,7 +1802,7 @@
           <p:cNvPr id="6" name="Slide Number Placeholder 5">
             <a:extLst xmlns:a="http://schemas.openxmlformats.org/drawingml/2006/main">
               <a:ext uri="{FF2B5EF4-FFF2-40B4-BE49-F238E27FC236}">
-                <a16:creationId xmlns:a16="http://schemas.microsoft.com/office/drawing/2014/main" id="{829E2942-F57D-4A99-9753-9267126D55A6}"/>
+                <a16:creationId xmlns:a16="http://schemas.microsoft.com/office/drawing/2014/main" id="{09747E73-CC9C-4DF9-8AAE-4AC46591EFE1}"/>
               </a:ext>
             </a:extLst>
           </p:cNvPr>
@@ -1847,7 +1847,7 @@
           <p:cNvPr id="2" name="Vertical Title 1">
             <a:extLst xmlns:a="http://schemas.openxmlformats.org/drawingml/2006/main">
               <a:ext uri="{FF2B5EF4-FFF2-40B4-BE49-F238E27FC236}">
-                <a16:creationId xmlns:a16="http://schemas.microsoft.com/office/drawing/2014/main" id="{2EBA4EA0-CF85-4D70-9F1F-E7D3760F4E66}"/>
+                <a16:creationId xmlns:a16="http://schemas.microsoft.com/office/drawing/2014/main" id="{A8701BF8-8142-407D-8E5B-A19EA21FD23D}"/>
               </a:ext>
             </a:extLst>
           </p:cNvPr>
@@ -1880,7 +1880,7 @@
           <p:cNvPr id="3" name="Vertical Text Placeholder 2">
             <a:extLst xmlns:a="http://schemas.openxmlformats.org/drawingml/2006/main">
               <a:ext uri="{FF2B5EF4-FFF2-40B4-BE49-F238E27FC236}">
-                <a16:creationId xmlns:a16="http://schemas.microsoft.com/office/drawing/2014/main" id="{76EA2E24-3B41-4099-978F-3C3A4460BD47}"/>
+                <a16:creationId xmlns:a16="http://schemas.microsoft.com/office/drawing/2014/main" id="{3D1E8C59-461C-4D5B-982F-BFA09C960514}"/>
               </a:ext>
             </a:extLst>
           </p:cNvPr>
@@ -1948,7 +1948,7 @@
           <p:cNvPr id="4" name="Date Placeholder 3">
             <a:extLst xmlns:a="http://schemas.openxmlformats.org/drawingml/2006/main">
               <a:ext uri="{FF2B5EF4-FFF2-40B4-BE49-F238E27FC236}">
-                <a16:creationId xmlns:a16="http://schemas.microsoft.com/office/drawing/2014/main" id="{D2EF0172-212B-4268-AEA3-C26B9977ECFA}"/>
+                <a16:creationId xmlns:a16="http://schemas.microsoft.com/office/drawing/2014/main" id="{886C2AB3-ECDC-473D-9539-D987564C9F6F}"/>
               </a:ext>
             </a:extLst>
           </p:cNvPr>
@@ -1976,7 +1976,7 @@
           <p:cNvPr id="5" name="Footer Placeholder 4">
             <a:extLst xmlns:a="http://schemas.openxmlformats.org/drawingml/2006/main">
               <a:ext uri="{FF2B5EF4-FFF2-40B4-BE49-F238E27FC236}">
-                <a16:creationId xmlns:a16="http://schemas.microsoft.com/office/drawing/2014/main" id="{3E99947C-0D4F-4192-98B9-59EBB54EC3C6}"/>
+                <a16:creationId xmlns:a16="http://schemas.microsoft.com/office/drawing/2014/main" id="{F9C6F6B7-5900-46E2-BA00-F11A92D61C99}"/>
               </a:ext>
             </a:extLst>
           </p:cNvPr>
@@ -2001,7 +2001,7 @@
           <p:cNvPr id="6" name="Slide Number Placeholder 5">
             <a:extLst xmlns:a="http://schemas.openxmlformats.org/drawingml/2006/main">
               <a:ext uri="{FF2B5EF4-FFF2-40B4-BE49-F238E27FC236}">
-                <a16:creationId xmlns:a16="http://schemas.microsoft.com/office/drawing/2014/main" id="{235F223B-F5A0-4EF6-A858-BF61F5D0AD52}"/>
+                <a16:creationId xmlns:a16="http://schemas.microsoft.com/office/drawing/2014/main" id="{8A14419A-600E-4D0A-8FA0-7FAAAB93DB6E}"/>
               </a:ext>
             </a:extLst>
           </p:cNvPr>
@@ -2046,7 +2046,7 @@
           <p:cNvPr id="2" name="Title 1">
             <a:extLst xmlns:a="http://schemas.openxmlformats.org/drawingml/2006/main">
               <a:ext uri="{FF2B5EF4-FFF2-40B4-BE49-F238E27FC236}">
-                <a16:creationId xmlns:a16="http://schemas.microsoft.com/office/drawing/2014/main" id="{E3E6E232-1505-4FD2-ADDC-4CC54EDD25A7}"/>
+                <a16:creationId xmlns:a16="http://schemas.microsoft.com/office/drawing/2014/main" id="{B44E379E-699A-4336-92B2-C40AE3537823}"/>
               </a:ext>
             </a:extLst>
           </p:cNvPr>
@@ -2074,7 +2074,7 @@
           <p:cNvPr id="3" name="Content Placeholder 2">
             <a:extLst xmlns:a="http://schemas.openxmlformats.org/drawingml/2006/main">
               <a:ext uri="{FF2B5EF4-FFF2-40B4-BE49-F238E27FC236}">
-                <a16:creationId xmlns:a16="http://schemas.microsoft.com/office/drawing/2014/main" id="{8D54F32B-8AE7-4A54-9109-BB1757462116}"/>
+                <a16:creationId xmlns:a16="http://schemas.microsoft.com/office/drawing/2014/main" id="{A30A1F42-718A-44DF-B78D-FB1B586155DC}"/>
               </a:ext>
             </a:extLst>
           </p:cNvPr>
@@ -2137,7 +2137,7 @@
           <p:cNvPr id="4" name="Date Placeholder 3">
             <a:extLst xmlns:a="http://schemas.openxmlformats.org/drawingml/2006/main">
               <a:ext uri="{FF2B5EF4-FFF2-40B4-BE49-F238E27FC236}">
-                <a16:creationId xmlns:a16="http://schemas.microsoft.com/office/drawing/2014/main" id="{56C6D15E-5756-4F32-9E04-ECF0A10EBD85}"/>
+                <a16:creationId xmlns:a16="http://schemas.microsoft.com/office/drawing/2014/main" id="{314BE9CA-2993-4473-BB65-6CE1FCE071B1}"/>
               </a:ext>
             </a:extLst>
           </p:cNvPr>
@@ -2165,7 +2165,7 @@
           <p:cNvPr id="5" name="Footer Placeholder 4">
             <a:extLst xmlns:a="http://schemas.openxmlformats.org/drawingml/2006/main">
               <a:ext uri="{FF2B5EF4-FFF2-40B4-BE49-F238E27FC236}">
-                <a16:creationId xmlns:a16="http://schemas.microsoft.com/office/drawing/2014/main" id="{8142D12A-F806-492C-9F5B-CE54FD0B4A3E}"/>
+                <a16:creationId xmlns:a16="http://schemas.microsoft.com/office/drawing/2014/main" id="{9AAA1245-4768-42B3-A33F-365BED43272D}"/>
               </a:ext>
             </a:extLst>
           </p:cNvPr>
@@ -2190,7 +2190,7 @@
           <p:cNvPr id="6" name="Slide Number Placeholder 5">
             <a:extLst xmlns:a="http://schemas.openxmlformats.org/drawingml/2006/main">
               <a:ext uri="{FF2B5EF4-FFF2-40B4-BE49-F238E27FC236}">
-                <a16:creationId xmlns:a16="http://schemas.microsoft.com/office/drawing/2014/main" id="{30FA304C-ED61-4FB8-B182-88552F9CD333}"/>
+                <a16:creationId xmlns:a16="http://schemas.microsoft.com/office/drawing/2014/main" id="{EAD63538-5A6F-48B7-8CDB-519A7F8D4593}"/>
               </a:ext>
             </a:extLst>
           </p:cNvPr>
@@ -2235,7 +2235,7 @@
           <p:cNvPr id="2" name="Title 1">
             <a:extLst xmlns:a="http://schemas.openxmlformats.org/drawingml/2006/main">
               <a:ext uri="{FF2B5EF4-FFF2-40B4-BE49-F238E27FC236}">
-                <a16:creationId xmlns:a16="http://schemas.microsoft.com/office/drawing/2014/main" id="{16300175-5F82-4443-ADA8-D93B634DF624}"/>
+                <a16:creationId xmlns:a16="http://schemas.microsoft.com/office/drawing/2014/main" id="{B601626C-3B6B-407C-8A8B-0AFB645AA1A8}"/>
               </a:ext>
             </a:extLst>
           </p:cNvPr>
@@ -2273,7 +2273,7 @@
           <p:cNvPr id="3" name="Text Placeholder 2">
             <a:extLst xmlns:a="http://schemas.openxmlformats.org/drawingml/2006/main">
               <a:ext uri="{FF2B5EF4-FFF2-40B4-BE49-F238E27FC236}">
-                <a16:creationId xmlns:a16="http://schemas.microsoft.com/office/drawing/2014/main" id="{0433C73D-B841-4943-8906-86080076D67C}"/>
+                <a16:creationId xmlns:a16="http://schemas.microsoft.com/office/drawing/2014/main" id="{09002309-6085-4FDF-A7B9-FB18CA920999}"/>
               </a:ext>
             </a:extLst>
           </p:cNvPr>
@@ -2399,7 +2399,7 @@
           <p:cNvPr id="4" name="Date Placeholder 3">
             <a:extLst xmlns:a="http://schemas.openxmlformats.org/drawingml/2006/main">
               <a:ext uri="{FF2B5EF4-FFF2-40B4-BE49-F238E27FC236}">
-                <a16:creationId xmlns:a16="http://schemas.microsoft.com/office/drawing/2014/main" id="{D63A1252-D79F-47CC-B7DB-52CD87BAC031}"/>
+                <a16:creationId xmlns:a16="http://schemas.microsoft.com/office/drawing/2014/main" id="{3802F0D4-CD28-4B8A-B7C4-D5FE76E8E75E}"/>
               </a:ext>
             </a:extLst>
           </p:cNvPr>
@@ -2427,7 +2427,7 @@
           <p:cNvPr id="5" name="Footer Placeholder 4">
             <a:extLst xmlns:a="http://schemas.openxmlformats.org/drawingml/2006/main">
               <a:ext uri="{FF2B5EF4-FFF2-40B4-BE49-F238E27FC236}">
-                <a16:creationId xmlns:a16="http://schemas.microsoft.com/office/drawing/2014/main" id="{E3F4273E-3D9A-4E12-BC42-30B4E0A2C3B3}"/>
+                <a16:creationId xmlns:a16="http://schemas.microsoft.com/office/drawing/2014/main" id="{6205E2FD-6504-48E5-9EA1-FF331F3DC009}"/>
               </a:ext>
             </a:extLst>
           </p:cNvPr>
@@ -2452,7 +2452,7 @@
           <p:cNvPr id="6" name="Slide Number Placeholder 5">
             <a:extLst xmlns:a="http://schemas.openxmlformats.org/drawingml/2006/main">
               <a:ext uri="{FF2B5EF4-FFF2-40B4-BE49-F238E27FC236}">
-                <a16:creationId xmlns:a16="http://schemas.microsoft.com/office/drawing/2014/main" id="{638455C1-0BF4-4D5A-B30A-6E58F740FA2D}"/>
+                <a16:creationId xmlns:a16="http://schemas.microsoft.com/office/drawing/2014/main" id="{DD69293F-5D61-4D16-9A44-B48A907F34B6}"/>
               </a:ext>
             </a:extLst>
           </p:cNvPr>
@@ -2497,7 +2497,7 @@
           <p:cNvPr id="2" name="Title 1">
             <a:extLst xmlns:a="http://schemas.openxmlformats.org/drawingml/2006/main">
               <a:ext uri="{FF2B5EF4-FFF2-40B4-BE49-F238E27FC236}">
-                <a16:creationId xmlns:a16="http://schemas.microsoft.com/office/drawing/2014/main" id="{46E12A8B-1165-4913-AC23-9E2191733A2E}"/>
+                <a16:creationId xmlns:a16="http://schemas.microsoft.com/office/drawing/2014/main" id="{521D26BB-4AAC-479E-9845-5949DEA961B6}"/>
               </a:ext>
             </a:extLst>
           </p:cNvPr>
@@ -2525,7 +2525,7 @@
           <p:cNvPr id="3" name="Content Placeholder 2">
             <a:extLst xmlns:a="http://schemas.openxmlformats.org/drawingml/2006/main">
               <a:ext uri="{FF2B5EF4-FFF2-40B4-BE49-F238E27FC236}">
-                <a16:creationId xmlns:a16="http://schemas.microsoft.com/office/drawing/2014/main" id="{8C2AD3CD-724B-4CCB-8183-C20027CE0831}"/>
+                <a16:creationId xmlns:a16="http://schemas.microsoft.com/office/drawing/2014/main" id="{8FC45983-8FB0-4CC5-B3E4-A4F1C6E800DD}"/>
               </a:ext>
             </a:extLst>
           </p:cNvPr>
@@ -2593,7 +2593,7 @@
           <p:cNvPr id="4" name="Content Placeholder 3">
             <a:extLst xmlns:a="http://schemas.openxmlformats.org/drawingml/2006/main">
               <a:ext uri="{FF2B5EF4-FFF2-40B4-BE49-F238E27FC236}">
-                <a16:creationId xmlns:a16="http://schemas.microsoft.com/office/drawing/2014/main" id="{669AA905-9FF5-4273-A560-DCCD826D0955}"/>
+                <a16:creationId xmlns:a16="http://schemas.microsoft.com/office/drawing/2014/main" id="{31B83C9C-F886-4A45-A722-98AB7946E0B7}"/>
               </a:ext>
             </a:extLst>
           </p:cNvPr>
@@ -2661,7 +2661,7 @@
           <p:cNvPr id="5" name="Date Placeholder 4">
             <a:extLst xmlns:a="http://schemas.openxmlformats.org/drawingml/2006/main">
               <a:ext uri="{FF2B5EF4-FFF2-40B4-BE49-F238E27FC236}">
-                <a16:creationId xmlns:a16="http://schemas.microsoft.com/office/drawing/2014/main" id="{C8A4AC2A-1485-4F11-A74F-97F5DE0BFDBE}"/>
+                <a16:creationId xmlns:a16="http://schemas.microsoft.com/office/drawing/2014/main" id="{C65D17EF-8F8A-4A09-8176-4796F992F3BA}"/>
               </a:ext>
             </a:extLst>
           </p:cNvPr>
@@ -2689,7 +2689,7 @@
           <p:cNvPr id="6" name="Footer Placeholder 5">
             <a:extLst xmlns:a="http://schemas.openxmlformats.org/drawingml/2006/main">
               <a:ext uri="{FF2B5EF4-FFF2-40B4-BE49-F238E27FC236}">
-                <a16:creationId xmlns:a16="http://schemas.microsoft.com/office/drawing/2014/main" id="{863C9977-4AAC-42C4-86B7-738C210F763C}"/>
+                <a16:creationId xmlns:a16="http://schemas.microsoft.com/office/drawing/2014/main" id="{4B4AEE9E-10C0-4D97-AF99-554DC9169B16}"/>
               </a:ext>
             </a:extLst>
           </p:cNvPr>
@@ -2714,7 +2714,7 @@
           <p:cNvPr id="7" name="Slide Number Placeholder 6">
             <a:extLst xmlns:a="http://schemas.openxmlformats.org/drawingml/2006/main">
               <a:ext uri="{FF2B5EF4-FFF2-40B4-BE49-F238E27FC236}">
-                <a16:creationId xmlns:a16="http://schemas.microsoft.com/office/drawing/2014/main" id="{32016986-0D25-40E4-9471-351F9830247D}"/>
+                <a16:creationId xmlns:a16="http://schemas.microsoft.com/office/drawing/2014/main" id="{E4E88BC0-5BB6-4072-B774-59FAFB592326}"/>
               </a:ext>
             </a:extLst>
           </p:cNvPr>
@@ -2759,7 +2759,7 @@
           <p:cNvPr id="2" name="Title 1">
             <a:extLst xmlns:a="http://schemas.openxmlformats.org/drawingml/2006/main">
               <a:ext uri="{FF2B5EF4-FFF2-40B4-BE49-F238E27FC236}">
-                <a16:creationId xmlns:a16="http://schemas.microsoft.com/office/drawing/2014/main" id="{6036E4DB-762D-49B8-B9C6-8943CCD591AF}"/>
+                <a16:creationId xmlns:a16="http://schemas.microsoft.com/office/drawing/2014/main" id="{13B90992-9B71-4B7E-B274-D75C325DF222}"/>
               </a:ext>
             </a:extLst>
           </p:cNvPr>
@@ -2792,7 +2792,7 @@
           <p:cNvPr id="3" name="Text Placeholder 2">
             <a:extLst xmlns:a="http://schemas.openxmlformats.org/drawingml/2006/main">
               <a:ext uri="{FF2B5EF4-FFF2-40B4-BE49-F238E27FC236}">
-                <a16:creationId xmlns:a16="http://schemas.microsoft.com/office/drawing/2014/main" id="{D23B69E9-1030-4EC4-9A9B-0994EBA18EC8}"/>
+                <a16:creationId xmlns:a16="http://schemas.microsoft.com/office/drawing/2014/main" id="{B850990D-C697-4EA9-BF0A-E03E98B82CD0}"/>
               </a:ext>
             </a:extLst>
           </p:cNvPr>
@@ -2864,7 +2864,7 @@
           <p:cNvPr id="4" name="Content Placeholder 3">
             <a:extLst xmlns:a="http://schemas.openxmlformats.org/drawingml/2006/main">
               <a:ext uri="{FF2B5EF4-FFF2-40B4-BE49-F238E27FC236}">
-                <a16:creationId xmlns:a16="http://schemas.microsoft.com/office/drawing/2014/main" id="{8E3D4BAC-9BA7-47C3-BAB2-7A152D31D5BF}"/>
+                <a16:creationId xmlns:a16="http://schemas.microsoft.com/office/drawing/2014/main" id="{D7C37648-47AE-4EC0-BDA9-B40018C59269}"/>
               </a:ext>
             </a:extLst>
           </p:cNvPr>
@@ -2932,7 +2932,7 @@
           <p:cNvPr id="5" name="Text Placeholder 4">
             <a:extLst xmlns:a="http://schemas.openxmlformats.org/drawingml/2006/main">
               <a:ext uri="{FF2B5EF4-FFF2-40B4-BE49-F238E27FC236}">
-                <a16:creationId xmlns:a16="http://schemas.microsoft.com/office/drawing/2014/main" id="{67BE825E-47F9-4224-9122-CC01F3398164}"/>
+                <a16:creationId xmlns:a16="http://schemas.microsoft.com/office/drawing/2014/main" id="{D26546FC-2DE1-4ACF-916E-86EC356DE3EF}"/>
               </a:ext>
             </a:extLst>
           </p:cNvPr>
@@ -3004,7 +3004,7 @@
           <p:cNvPr id="6" name="Content Placeholder 5">
             <a:extLst xmlns:a="http://schemas.openxmlformats.org/drawingml/2006/main">
               <a:ext uri="{FF2B5EF4-FFF2-40B4-BE49-F238E27FC236}">
-                <a16:creationId xmlns:a16="http://schemas.microsoft.com/office/drawing/2014/main" id="{649CA2D9-C142-4926-9751-F0BC4D4156D7}"/>
+                <a16:creationId xmlns:a16="http://schemas.microsoft.com/office/drawing/2014/main" id="{C4F26F22-6E5F-4F91-8E6D-A1C29C3C02CB}"/>
               </a:ext>
             </a:extLst>
           </p:cNvPr>
@@ -3072,7 +3072,7 @@
           <p:cNvPr id="7" name="Date Placeholder 6">
             <a:extLst xmlns:a="http://schemas.openxmlformats.org/drawingml/2006/main">
               <a:ext uri="{FF2B5EF4-FFF2-40B4-BE49-F238E27FC236}">
-                <a16:creationId xmlns:a16="http://schemas.microsoft.com/office/drawing/2014/main" id="{A3CAC650-9D1A-46FC-AFF3-4F630B945086}"/>
+                <a16:creationId xmlns:a16="http://schemas.microsoft.com/office/drawing/2014/main" id="{4DE2B733-C605-4E7C-9A5C-BE69206C9CCB}"/>
               </a:ext>
             </a:extLst>
           </p:cNvPr>
@@ -3100,7 +3100,7 @@
           <p:cNvPr id="8" name="Footer Placeholder 7">
             <a:extLst xmlns:a="http://schemas.openxmlformats.org/drawingml/2006/main">
               <a:ext uri="{FF2B5EF4-FFF2-40B4-BE49-F238E27FC236}">
-                <a16:creationId xmlns:a16="http://schemas.microsoft.com/office/drawing/2014/main" id="{A0AD0715-888E-4540-A763-914639AF2241}"/>
+                <a16:creationId xmlns:a16="http://schemas.microsoft.com/office/drawing/2014/main" id="{8F2A94F7-D29F-46B4-97E5-44720FA477FD}"/>
               </a:ext>
             </a:extLst>
           </p:cNvPr>
@@ -3125,7 +3125,7 @@
           <p:cNvPr id="9" name="Slide Number Placeholder 8">
             <a:extLst xmlns:a="http://schemas.openxmlformats.org/drawingml/2006/main">
               <a:ext uri="{FF2B5EF4-FFF2-40B4-BE49-F238E27FC236}">
-                <a16:creationId xmlns:a16="http://schemas.microsoft.com/office/drawing/2014/main" id="{A7B3177F-D4A1-40E4-89CD-D49B75A89291}"/>
+                <a16:creationId xmlns:a16="http://schemas.microsoft.com/office/drawing/2014/main" id="{1AC81C9C-2848-4301-BCC6-D831322B1DD0}"/>
               </a:ext>
             </a:extLst>
           </p:cNvPr>
@@ -3170,7 +3170,7 @@
           <p:cNvPr id="2" name="Title 1">
             <a:extLst xmlns:a="http://schemas.openxmlformats.org/drawingml/2006/main">
               <a:ext uri="{FF2B5EF4-FFF2-40B4-BE49-F238E27FC236}">
-                <a16:creationId xmlns:a16="http://schemas.microsoft.com/office/drawing/2014/main" id="{AD61C91C-4274-4318-8E69-B9635F57A0A8}"/>
+                <a16:creationId xmlns:a16="http://schemas.microsoft.com/office/drawing/2014/main" id="{8E9B9535-21EC-4565-9316-D7BE54DF5659}"/>
               </a:ext>
             </a:extLst>
           </p:cNvPr>
@@ -3198,7 +3198,7 @@
           <p:cNvPr id="3" name="Date Placeholder 2">
             <a:extLst xmlns:a="http://schemas.openxmlformats.org/drawingml/2006/main">
               <a:ext uri="{FF2B5EF4-FFF2-40B4-BE49-F238E27FC236}">
-                <a16:creationId xmlns:a16="http://schemas.microsoft.com/office/drawing/2014/main" id="{374968D1-2302-4B79-ADBD-303542ED3539}"/>
+                <a16:creationId xmlns:a16="http://schemas.microsoft.com/office/drawing/2014/main" id="{DE162F27-312F-4B1C-9965-5975063529B0}"/>
               </a:ext>
             </a:extLst>
           </p:cNvPr>
@@ -3226,7 +3226,7 @@
           <p:cNvPr id="4" name="Footer Placeholder 3">
             <a:extLst xmlns:a="http://schemas.openxmlformats.org/drawingml/2006/main">
               <a:ext uri="{FF2B5EF4-FFF2-40B4-BE49-F238E27FC236}">
-                <a16:creationId xmlns:a16="http://schemas.microsoft.com/office/drawing/2014/main" id="{28E56A25-9E47-4C87-A9CA-40214A699862}"/>
+                <a16:creationId xmlns:a16="http://schemas.microsoft.com/office/drawing/2014/main" id="{BC39294A-8C0C-4FC3-8A1A-45172DB5E834}"/>
               </a:ext>
             </a:extLst>
           </p:cNvPr>
@@ -3251,7 +3251,7 @@
           <p:cNvPr id="5" name="Slide Number Placeholder 4">
             <a:extLst xmlns:a="http://schemas.openxmlformats.org/drawingml/2006/main">
               <a:ext uri="{FF2B5EF4-FFF2-40B4-BE49-F238E27FC236}">
-                <a16:creationId xmlns:a16="http://schemas.microsoft.com/office/drawing/2014/main" id="{A23646C4-1B51-405C-B369-D2381D127654}"/>
+                <a16:creationId xmlns:a16="http://schemas.microsoft.com/office/drawing/2014/main" id="{70580E6C-3124-454C-9424-BBF9566B36EC}"/>
               </a:ext>
             </a:extLst>
           </p:cNvPr>
@@ -3296,7 +3296,7 @@
           <p:cNvPr id="2" name="Date Placeholder 1">
             <a:extLst xmlns:a="http://schemas.openxmlformats.org/drawingml/2006/main">
               <a:ext uri="{FF2B5EF4-FFF2-40B4-BE49-F238E27FC236}">
-                <a16:creationId xmlns:a16="http://schemas.microsoft.com/office/drawing/2014/main" id="{9E112F68-E11A-43BC-8E85-E32B4485D7D8}"/>
+                <a16:creationId xmlns:a16="http://schemas.microsoft.com/office/drawing/2014/main" id="{5C8C8B7D-ADD3-46F6-88DA-5085B9EC53C4}"/>
               </a:ext>
             </a:extLst>
           </p:cNvPr>
@@ -3324,7 +3324,7 @@
           <p:cNvPr id="3" name="Footer Placeholder 2">
             <a:extLst xmlns:a="http://schemas.openxmlformats.org/drawingml/2006/main">
               <a:ext uri="{FF2B5EF4-FFF2-40B4-BE49-F238E27FC236}">
-                <a16:creationId xmlns:a16="http://schemas.microsoft.com/office/drawing/2014/main" id="{FE3F4271-95BD-4797-8043-ECD004A9A71A}"/>
+                <a16:creationId xmlns:a16="http://schemas.microsoft.com/office/drawing/2014/main" id="{41BC4F0B-2B45-44DC-9B0F-6BB8C64E8EF9}"/>
               </a:ext>
             </a:extLst>
           </p:cNvPr>
@@ -3349,7 +3349,7 @@
           <p:cNvPr id="4" name="Slide Number Placeholder 3">
             <a:extLst xmlns:a="http://schemas.openxmlformats.org/drawingml/2006/main">
               <a:ext uri="{FF2B5EF4-FFF2-40B4-BE49-F238E27FC236}">
-                <a16:creationId xmlns:a16="http://schemas.microsoft.com/office/drawing/2014/main" id="{05AB8F9D-86A8-47E1-988F-B7648D3D138D}"/>
+                <a16:creationId xmlns:a16="http://schemas.microsoft.com/office/drawing/2014/main" id="{8318AF34-40B3-4876-B530-AE0E7851DFA9}"/>
               </a:ext>
             </a:extLst>
           </p:cNvPr>
@@ -3394,7 +3394,7 @@
           <p:cNvPr id="2" name="Title 1">
             <a:extLst xmlns:a="http://schemas.openxmlformats.org/drawingml/2006/main">
               <a:ext uri="{FF2B5EF4-FFF2-40B4-BE49-F238E27FC236}">
-                <a16:creationId xmlns:a16="http://schemas.microsoft.com/office/drawing/2014/main" id="{05FC92E7-F987-4E77-AA68-C83CD6A1953A}"/>
+                <a16:creationId xmlns:a16="http://schemas.microsoft.com/office/drawing/2014/main" id="{626AFD48-E2CE-4A94-A101-4982A5E28EDE}"/>
               </a:ext>
             </a:extLst>
           </p:cNvPr>
@@ -3432,7 +3432,7 @@
           <p:cNvPr id="3" name="Content Placeholder 2">
             <a:extLst xmlns:a="http://schemas.openxmlformats.org/drawingml/2006/main">
               <a:ext uri="{FF2B5EF4-FFF2-40B4-BE49-F238E27FC236}">
-                <a16:creationId xmlns:a16="http://schemas.microsoft.com/office/drawing/2014/main" id="{622EEB74-F6A0-4C87-8DB2-352441858EA1}"/>
+                <a16:creationId xmlns:a16="http://schemas.microsoft.com/office/drawing/2014/main" id="{D49965D2-5F9B-48E3-99FF-2AE30B577584}"/>
               </a:ext>
             </a:extLst>
           </p:cNvPr>
@@ -3537,7 +3537,7 @@
           <p:cNvPr id="4" name="Text Placeholder 3">
             <a:extLst xmlns:a="http://schemas.openxmlformats.org/drawingml/2006/main">
               <a:ext uri="{FF2B5EF4-FFF2-40B4-BE49-F238E27FC236}">
-                <a16:creationId xmlns:a16="http://schemas.microsoft.com/office/drawing/2014/main" id="{D4C30400-7233-4768-9C98-DD47F5CAD419}"/>
+                <a16:creationId xmlns:a16="http://schemas.microsoft.com/office/drawing/2014/main" id="{820D7D3B-9EC6-4B08-8A07-3CD5FE7BB371}"/>
               </a:ext>
             </a:extLst>
           </p:cNvPr>
@@ -3609,7 +3609,7 @@
           <p:cNvPr id="5" name="Date Placeholder 4">
             <a:extLst xmlns:a="http://schemas.openxmlformats.org/drawingml/2006/main">
               <a:ext uri="{FF2B5EF4-FFF2-40B4-BE49-F238E27FC236}">
-                <a16:creationId xmlns:a16="http://schemas.microsoft.com/office/drawing/2014/main" id="{DCAA723B-3DBE-4B37-B390-9F608B31C2AC}"/>
+                <a16:creationId xmlns:a16="http://schemas.microsoft.com/office/drawing/2014/main" id="{12A5BFD9-B368-48BE-9525-CF87A2213960}"/>
               </a:ext>
             </a:extLst>
           </p:cNvPr>
@@ -3637,7 +3637,7 @@
           <p:cNvPr id="6" name="Footer Placeholder 5">
             <a:extLst xmlns:a="http://schemas.openxmlformats.org/drawingml/2006/main">
               <a:ext uri="{FF2B5EF4-FFF2-40B4-BE49-F238E27FC236}">
-                <a16:creationId xmlns:a16="http://schemas.microsoft.com/office/drawing/2014/main" id="{454A18D0-781E-4BD9-9553-E9494091FFFF}"/>
+                <a16:creationId xmlns:a16="http://schemas.microsoft.com/office/drawing/2014/main" id="{49CCE4A3-0C26-45AD-8B52-74A927F87464}"/>
               </a:ext>
             </a:extLst>
           </p:cNvPr>
@@ -3662,7 +3662,7 @@
           <p:cNvPr id="7" name="Slide Number Placeholder 6">
             <a:extLst xmlns:a="http://schemas.openxmlformats.org/drawingml/2006/main">
               <a:ext uri="{FF2B5EF4-FFF2-40B4-BE49-F238E27FC236}">
-                <a16:creationId xmlns:a16="http://schemas.microsoft.com/office/drawing/2014/main" id="{CF7CE002-460A-4238-A4FD-F01B135332F9}"/>
+                <a16:creationId xmlns:a16="http://schemas.microsoft.com/office/drawing/2014/main" id="{EAA12C86-9A81-4AEE-B5CB-4B987619A327}"/>
               </a:ext>
             </a:extLst>
           </p:cNvPr>
@@ -3707,7 +3707,7 @@
           <p:cNvPr id="2" name="Title 1">
             <a:extLst xmlns:a="http://schemas.openxmlformats.org/drawingml/2006/main">
               <a:ext uri="{FF2B5EF4-FFF2-40B4-BE49-F238E27FC236}">
-                <a16:creationId xmlns:a16="http://schemas.microsoft.com/office/drawing/2014/main" id="{107F2948-76B4-48B9-8436-0727922D0CB1}"/>
+                <a16:creationId xmlns:a16="http://schemas.microsoft.com/office/drawing/2014/main" id="{FE1F3307-3D54-414F-93AB-62E493C32419}"/>
               </a:ext>
             </a:extLst>
           </p:cNvPr>
@@ -3745,7 +3745,7 @@
           <p:cNvPr id="3" name="Picture Placeholder 2">
             <a:extLst xmlns:a="http://schemas.openxmlformats.org/drawingml/2006/main">
               <a:ext uri="{FF2B5EF4-FFF2-40B4-BE49-F238E27FC236}">
-                <a16:creationId xmlns:a16="http://schemas.microsoft.com/office/drawing/2014/main" id="{27808275-D54D-48DE-9977-8953946667F3}"/>
+                <a16:creationId xmlns:a16="http://schemas.microsoft.com/office/drawing/2014/main" id="{83E799E6-CEBE-4739-98D7-2CF0DEF223A3}"/>
               </a:ext>
             </a:extLst>
           </p:cNvPr>
@@ -3812,7 +3812,7 @@
           <p:cNvPr id="4" name="Text Placeholder 3">
             <a:extLst xmlns:a="http://schemas.openxmlformats.org/drawingml/2006/main">
               <a:ext uri="{FF2B5EF4-FFF2-40B4-BE49-F238E27FC236}">
-                <a16:creationId xmlns:a16="http://schemas.microsoft.com/office/drawing/2014/main" id="{4C2170BA-1724-408B-A502-415A0F36F6B3}"/>
+                <a16:creationId xmlns:a16="http://schemas.microsoft.com/office/drawing/2014/main" id="{954D891B-277E-4939-813A-92EC0EC324A7}"/>
               </a:ext>
             </a:extLst>
           </p:cNvPr>
@@ -3884,7 +3884,7 @@
           <p:cNvPr id="5" name="Date Placeholder 4">
             <a:extLst xmlns:a="http://schemas.openxmlformats.org/drawingml/2006/main">
               <a:ext uri="{FF2B5EF4-FFF2-40B4-BE49-F238E27FC236}">
-                <a16:creationId xmlns:a16="http://schemas.microsoft.com/office/drawing/2014/main" id="{7CD5342C-CAF8-42D0-8D36-C2C888EE5454}"/>
+                <a16:creationId xmlns:a16="http://schemas.microsoft.com/office/drawing/2014/main" id="{76610F39-C12E-4256-84EA-3DE034668B08}"/>
               </a:ext>
             </a:extLst>
           </p:cNvPr>
@@ -3912,7 +3912,7 @@
           <p:cNvPr id="6" name="Footer Placeholder 5">
             <a:extLst xmlns:a="http://schemas.openxmlformats.org/drawingml/2006/main">
               <a:ext uri="{FF2B5EF4-FFF2-40B4-BE49-F238E27FC236}">
-                <a16:creationId xmlns:a16="http://schemas.microsoft.com/office/drawing/2014/main" id="{87BF8223-CD36-4061-990F-7FAA6B8201FA}"/>
+                <a16:creationId xmlns:a16="http://schemas.microsoft.com/office/drawing/2014/main" id="{081E2209-78A2-4010-926D-15516BD41FA5}"/>
               </a:ext>
             </a:extLst>
           </p:cNvPr>
@@ -3937,7 +3937,7 @@
           <p:cNvPr id="7" name="Slide Number Placeholder 6">
             <a:extLst xmlns:a="http://schemas.openxmlformats.org/drawingml/2006/main">
               <a:ext uri="{FF2B5EF4-FFF2-40B4-BE49-F238E27FC236}">
-                <a16:creationId xmlns:a16="http://schemas.microsoft.com/office/drawing/2014/main" id="{52AC789D-36BF-483B-86C7-84C8E8F64F94}"/>
+                <a16:creationId xmlns:a16="http://schemas.microsoft.com/office/drawing/2014/main" id="{2F9AFA67-F76C-45B2-94CB-74DD8A87156E}"/>
               </a:ext>
             </a:extLst>
           </p:cNvPr>
@@ -3987,7 +3987,7 @@
           <p:cNvPr id="2" name="Title Placeholder 1">
             <a:extLst xmlns:a="http://schemas.openxmlformats.org/drawingml/2006/main">
               <a:ext uri="{FF2B5EF4-FFF2-40B4-BE49-F238E27FC236}">
-                <a16:creationId xmlns:a16="http://schemas.microsoft.com/office/drawing/2014/main" id="{3D747363-04EC-459A-BD79-EE6D6B42A09C}"/>
+                <a16:creationId xmlns:a16="http://schemas.microsoft.com/office/drawing/2014/main" id="{75E39032-2E06-44EA-A69B-B4C409301F98}"/>
               </a:ext>
             </a:extLst>
           </p:cNvPr>
@@ -4025,7 +4025,7 @@
           <p:cNvPr id="3" name="Text Placeholder 2">
             <a:extLst xmlns:a="http://schemas.openxmlformats.org/drawingml/2006/main">
               <a:ext uri="{FF2B5EF4-FFF2-40B4-BE49-F238E27FC236}">
-                <a16:creationId xmlns:a16="http://schemas.microsoft.com/office/drawing/2014/main" id="{E87A1D8B-4458-438F-BE79-1921EB6DBAF9}"/>
+                <a16:creationId xmlns:a16="http://schemas.microsoft.com/office/drawing/2014/main" id="{A5528075-C618-44CC-9589-9B3520B50222}"/>
               </a:ext>
             </a:extLst>
           </p:cNvPr>
@@ -4098,7 +4098,7 @@
           <p:cNvPr id="4" name="Date Placeholder 3">
             <a:extLst xmlns:a="http://schemas.openxmlformats.org/drawingml/2006/main">
               <a:ext uri="{FF2B5EF4-FFF2-40B4-BE49-F238E27FC236}">
-                <a16:creationId xmlns:a16="http://schemas.microsoft.com/office/drawing/2014/main" id="{26D1F3D7-7CDB-4385-9C41-55C04C6CB9CC}"/>
+                <a16:creationId xmlns:a16="http://schemas.microsoft.com/office/drawing/2014/main" id="{D13CFC37-1647-45CD-B52C-296710E58D18}"/>
               </a:ext>
             </a:extLst>
           </p:cNvPr>
@@ -4145,7 +4145,7 @@
           <p:cNvPr id="5" name="Footer Placeholder 4">
             <a:extLst xmlns:a="http://schemas.openxmlformats.org/drawingml/2006/main">
               <a:ext uri="{FF2B5EF4-FFF2-40B4-BE49-F238E27FC236}">
-                <a16:creationId xmlns:a16="http://schemas.microsoft.com/office/drawing/2014/main" id="{99E13E3B-513E-40C0-A612-F8CA632C8670}"/>
+                <a16:creationId xmlns:a16="http://schemas.microsoft.com/office/drawing/2014/main" id="{4965F549-C89B-4F52-87B7-763F6DD87317}"/>
               </a:ext>
             </a:extLst>
           </p:cNvPr>
@@ -4189,7 +4189,7 @@
           <p:cNvPr id="6" name="Slide Number Placeholder 5">
             <a:extLst xmlns:a="http://schemas.openxmlformats.org/drawingml/2006/main">
               <a:ext uri="{FF2B5EF4-FFF2-40B4-BE49-F238E27FC236}">
-                <a16:creationId xmlns:a16="http://schemas.microsoft.com/office/drawing/2014/main" id="{9A9A833A-C603-4C56-AD60-F0CDA190D1C9}"/>
+                <a16:creationId xmlns:a16="http://schemas.microsoft.com/office/drawing/2014/main" id="{02614DCF-02D7-4E6B-BA3D-5113BEED363C}"/>
               </a:ext>
             </a:extLst>
           </p:cNvPr>
@@ -4235,17 +4235,17 @@
   </p:cSld>
   <p:clrMap bg1="lt1" tx1="dk1" bg2="lt2" tx2="dk2" accent1="accent1" accent2="accent2" accent3="accent3" accent4="accent4" accent5="accent5" accent6="accent6" hlink="hlink" folHlink="folHlink"/>
   <p:sldLayoutIdLst>
-    <p:sldLayoutId xmlns:r="http://schemas.openxmlformats.org/officeDocument/2006/relationships" id="2147483649" r:id="R82c1a721e72e455d"/>
-    <p:sldLayoutId xmlns:r="http://schemas.openxmlformats.org/officeDocument/2006/relationships" id="2147483650" r:id="R92a2e5938c004fee"/>
-    <p:sldLayoutId xmlns:r="http://schemas.openxmlformats.org/officeDocument/2006/relationships" id="2147483651" r:id="Ra549adf6dc3644fd"/>
-    <p:sldLayoutId xmlns:r="http://schemas.openxmlformats.org/officeDocument/2006/relationships" id="2147483652" r:id="R1f935bb8e9ed4f82"/>
-    <p:sldLayoutId xmlns:r="http://schemas.openxmlformats.org/officeDocument/2006/relationships" id="2147483653" r:id="Rb84808408bf34440"/>
-    <p:sldLayoutId xmlns:r="http://schemas.openxmlformats.org/officeDocument/2006/relationships" id="2147483654" r:id="R1406441b335b4184"/>
-    <p:sldLayoutId xmlns:r="http://schemas.openxmlformats.org/officeDocument/2006/relationships" id="2147483655" r:id="R73cf0764e6664041"/>
-    <p:sldLayoutId xmlns:r="http://schemas.openxmlformats.org/officeDocument/2006/relationships" id="2147483656" r:id="R573b60a9314e4214"/>
-    <p:sldLayoutId xmlns:r="http://schemas.openxmlformats.org/officeDocument/2006/relationships" id="2147483657" r:id="Rebdd22aa9f784fb3"/>
-    <p:sldLayoutId xmlns:r="http://schemas.openxmlformats.org/officeDocument/2006/relationships" id="2147483658" r:id="Rf0215cce29514fea"/>
-    <p:sldLayoutId xmlns:r="http://schemas.openxmlformats.org/officeDocument/2006/relationships" id="2147483659" r:id="Rb090bebeb53c4507"/>
+    <p:sldLayoutId xmlns:r="http://schemas.openxmlformats.org/officeDocument/2006/relationships" id="2147483649" r:id="R840b1887805141ff"/>
+    <p:sldLayoutId xmlns:r="http://schemas.openxmlformats.org/officeDocument/2006/relationships" id="2147483650" r:id="R67878c88d16941af"/>
+    <p:sldLayoutId xmlns:r="http://schemas.openxmlformats.org/officeDocument/2006/relationships" id="2147483651" r:id="Re295881707e94848"/>
+    <p:sldLayoutId xmlns:r="http://schemas.openxmlformats.org/officeDocument/2006/relationships" id="2147483652" r:id="R9528433ccd6c4f1b"/>
+    <p:sldLayoutId xmlns:r="http://schemas.openxmlformats.org/officeDocument/2006/relationships" id="2147483653" r:id="R200199b2db26469c"/>
+    <p:sldLayoutId xmlns:r="http://schemas.openxmlformats.org/officeDocument/2006/relationships" id="2147483654" r:id="R888887b3324044f8"/>
+    <p:sldLayoutId xmlns:r="http://schemas.openxmlformats.org/officeDocument/2006/relationships" id="2147483655" r:id="Rc02790c4b5a54c9f"/>
+    <p:sldLayoutId xmlns:r="http://schemas.openxmlformats.org/officeDocument/2006/relationships" id="2147483656" r:id="Rd345455bc671437e"/>
+    <p:sldLayoutId xmlns:r="http://schemas.openxmlformats.org/officeDocument/2006/relationships" id="2147483657" r:id="R039b3b6f26c34d8d"/>
+    <p:sldLayoutId xmlns:r="http://schemas.openxmlformats.org/officeDocument/2006/relationships" id="2147483658" r:id="R8f9a946136344457"/>
+    <p:sldLayoutId xmlns:r="http://schemas.openxmlformats.org/officeDocument/2006/relationships" id="2147483659" r:id="Rd49a2a44a9434ad4"/>
   </p:sldLayoutIdLst>
   <p:txStyles>
     <p:titleStyle>
@@ -4804,7 +4804,7 @@
           <p:cNvPr id="2" name="Title 1">
             <a:extLst xmlns:a="http://schemas.openxmlformats.org/drawingml/2006/main">
               <a:ext uri="{FF2B5EF4-FFF2-40B4-BE49-F238E27FC236}">
-                <a16:creationId xmlns:a16="http://schemas.microsoft.com/office/drawing/2014/main" id="{9E0200F7-1704-45B1-8695-E3BE819BDC03}"/>
+                <a16:creationId xmlns:a16="http://schemas.microsoft.com/office/drawing/2014/main" id="{6CF967BC-7F92-467A-8248-E3EA1CA36C2F}"/>
               </a:ext>
             </a:extLst>
           </p:cNvPr>
@@ -4817,8 +4817,8 @@
         </p:nvSpPr>
         <p:spPr>
           <a:xfrm xmlns:a="http://schemas.openxmlformats.org/drawingml/2006/main">
-            <a:off x="6238875" y="1666875"/>
-            <a:ext cx="5619750" cy="3333750"/>
+            <a:off x="6238875" y="1095375"/>
+            <a:ext cx="5619750" cy="4048125"/>
           </a:xfrm>
         </p:spPr>
         <p:txBody>
@@ -4829,7 +4829,7 @@
           <a:p xmlns:a="http://schemas.openxmlformats.org/drawingml/2006/main">
             <a:pPr algn="l">
               <a:buNone/>
-              <a:defRPr sz="2025">
+              <a:defRPr sz="1875">
                 <a:solidFill>
                   <a:srgbClr val="222C38"/>
                 </a:solidFill>
@@ -4839,7 +4839,7 @@
               </a:defRPr>
             </a:pPr>
             <a:r>
-              <a:rPr sz="2025">
+              <a:rPr sz="1875">
                 <a:solidFill>
                   <a:srgbClr val="222C38"/>
                 </a:solidFill>
@@ -4853,7 +4853,7 @@
           <a:p xmlns:a="http://schemas.openxmlformats.org/drawingml/2006/main">
             <a:pPr algn="l">
               <a:buNone/>
-              <a:defRPr sz="2025">
+              <a:defRPr sz="1875">
                 <a:solidFill>
                   <a:srgbClr val="222C38"/>
                 </a:solidFill>
@@ -4863,7 +4863,7 @@
               </a:defRPr>
             </a:pPr>
             <a:r>
-              <a:rPr sz="2025">
+              <a:rPr sz="1875">
                 <a:solidFill>
                   <a:srgbClr val="222C38"/>
                 </a:solidFill>
@@ -4871,12 +4871,36 @@
                 <a:ea typeface="PF Centro Sans Pro"/>
                 <a:cs typeface="PF Centro Sans Pro"/>
               </a:rPr>
-              <a:t>Видеоаналитика охраны труда</a:t>
+              <a:t>Платформа видеоаналитики</a:t>
             </a:r>
           </a:p>
           <a:p xmlns:a="http://schemas.openxmlformats.org/drawingml/2006/main">
             <a:pPr algn="l">
               <a:buNone/>
+              <a:defRPr sz="1875">
+                <a:solidFill>
+                  <a:srgbClr val="222C38"/>
+                </a:solidFill>
+                <a:latin typeface="PF Centro Sans Pro"/>
+                <a:ea typeface="PF Centro Sans Pro"/>
+                <a:cs typeface="PF Centro Sans Pro"/>
+              </a:defRPr>
+            </a:pPr>
+            <a:r>
+              <a:rPr sz="1875">
+                <a:solidFill>
+                  <a:srgbClr val="222C38"/>
+                </a:solidFill>
+                <a:latin typeface="PF Centro Sans Pro"/>
+                <a:ea typeface="PF Centro Sans Pro"/>
+                <a:cs typeface="PF Centro Sans Pro"/>
+              </a:rPr>
+              <a:t>для контроля охраны труда</a:t>
+            </a:r>
+          </a:p>
+          <a:p xmlns:a="http://schemas.openxmlformats.org/drawingml/2006/main">
+            <a:pPr algn="l">
+              <a:buNone/>
             </a:pPr>
             <a:r>
               <a:t/>
@@ -4885,7 +4909,7 @@
           <a:p xmlns:a="http://schemas.openxmlformats.org/drawingml/2006/main">
             <a:pPr algn="l">
               <a:buNone/>
-              <a:defRPr sz="2025">
+              <a:defRPr sz="1875">
                 <a:solidFill>
                   <a:srgbClr val="222C38"/>
                 </a:solidFill>
@@ -4895,7 +4919,7 @@
               </a:defRPr>
             </a:pPr>
             <a:r>
-              <a:rPr sz="2025">
+              <a:rPr sz="1875">
                 <a:solidFill>
                   <a:srgbClr val="222C38"/>
                 </a:solidFill>
@@ -4909,7 +4933,7 @@
           <a:p xmlns:a="http://schemas.openxmlformats.org/drawingml/2006/main">
             <a:pPr algn="l">
               <a:buNone/>
-              <a:defRPr sz="2025">
+              <a:defRPr sz="1875">
                 <a:solidFill>
                   <a:srgbClr val="222C38"/>
                 </a:solidFill>
@@ -4919,7 +4943,7 @@
               </a:defRPr>
             </a:pPr>
             <a:r>
-              <a:rPr sz="2025">
+              <a:rPr sz="1875">
                 <a:solidFill>
                   <a:srgbClr val="222C38"/>
                 </a:solidFill>
@@ -4933,6 +4957,54 @@
           <a:p xmlns:a="http://schemas.openxmlformats.org/drawingml/2006/main">
             <a:pPr algn="l">
               <a:buNone/>
+              <a:defRPr sz="1875">
+                <a:solidFill>
+                  <a:srgbClr val="222C38"/>
+                </a:solidFill>
+                <a:latin typeface="PF Centro Sans Pro"/>
+                <a:ea typeface="PF Centro Sans Pro"/>
+                <a:cs typeface="PF Centro Sans Pro"/>
+              </a:defRPr>
+            </a:pPr>
+            <a:r>
+              <a:rPr sz="1875">
+                <a:solidFill>
+                  <a:srgbClr val="222C38"/>
+                </a:solidFill>
+                <a:latin typeface="PF Centro Sans Pro"/>
+                <a:ea typeface="PF Centro Sans Pro"/>
+                <a:cs typeface="PF Centro Sans Pro"/>
+              </a:rPr>
+              <a:t>Фролов Денис</a:t>
+            </a:r>
+          </a:p>
+          <a:p xmlns:a="http://schemas.openxmlformats.org/drawingml/2006/main">
+            <a:pPr algn="l">
+              <a:buNone/>
+              <a:defRPr sz="1875">
+                <a:solidFill>
+                  <a:srgbClr val="222C38"/>
+                </a:solidFill>
+                <a:latin typeface="PF Centro Sans Pro"/>
+                <a:ea typeface="PF Centro Sans Pro"/>
+                <a:cs typeface="PF Centro Sans Pro"/>
+              </a:defRPr>
+            </a:pPr>
+            <a:r>
+              <a:rPr sz="1875">
+                <a:solidFill>
+                  <a:srgbClr val="222C38"/>
+                </a:solidFill>
+                <a:latin typeface="PF Centro Sans Pro"/>
+                <a:ea typeface="PF Centro Sans Pro"/>
+                <a:cs typeface="PF Centro Sans Pro"/>
+              </a:rPr>
+              <a:t>Разработчик программной платформы</a:t>
+            </a:r>
+          </a:p>
+          <a:p xmlns:a="http://schemas.openxmlformats.org/drawingml/2006/main">
+            <a:pPr algn="l">
+              <a:buNone/>
             </a:pPr>
             <a:r>
               <a:t/>
@@ -4941,7 +5013,7 @@
           <a:p xmlns:a="http://schemas.openxmlformats.org/drawingml/2006/main">
             <a:pPr algn="l">
               <a:buNone/>
-              <a:defRPr sz="2025">
+              <a:defRPr sz="1875">
                 <a:solidFill>
                   <a:srgbClr val="222C38"/>
                 </a:solidFill>
@@ -4951,7 +5023,7 @@
               </a:defRPr>
             </a:pPr>
             <a:r>
-              <a:rPr sz="2025">
+              <a:rPr sz="1875">
                 <a:solidFill>
                   <a:srgbClr val="222C38"/>
                 </a:solidFill>
@@ -4965,7 +5037,7 @@
           <a:p xmlns:a="http://schemas.openxmlformats.org/drawingml/2006/main">
             <a:pPr algn="l">
               <a:buNone/>
-              <a:defRPr sz="2025">
+              <a:defRPr sz="1875">
                 <a:solidFill>
                   <a:srgbClr val="222C38"/>
                 </a:solidFill>
@@ -4975,7 +5047,7 @@
               </a:defRPr>
             </a:pPr>
             <a:r>
-              <a:rPr sz="2025">
+              <a:rPr sz="1875">
                 <a:solidFill>
                   <a:srgbClr val="222C38"/>
                 </a:solidFill>
@@ -4983,31 +5055,7 @@
                 <a:ea typeface="PF Centro Sans Pro"/>
                 <a:cs typeface="PF Centro Sans Pro"/>
               </a:rPr>
-              <a:t>+7 987 663-19-62</a:t>
-            </a:r>
-          </a:p>
-          <a:p xmlns:a="http://schemas.openxmlformats.org/drawingml/2006/main">
-            <a:pPr algn="l">
-              <a:buNone/>
-              <a:defRPr sz="2025">
-                <a:solidFill>
-                  <a:srgbClr val="222C38"/>
-                </a:solidFill>
-                <a:latin typeface="PF Centro Sans Pro"/>
-                <a:ea typeface="PF Centro Sans Pro"/>
-                <a:cs typeface="PF Centro Sans Pro"/>
-              </a:defRPr>
-            </a:pPr>
-            <a:r>
-              <a:rPr sz="2025">
-                <a:solidFill>
-                  <a:srgbClr val="222C38"/>
-                </a:solidFill>
-                <a:latin typeface="PF Centro Sans Pro"/>
-                <a:ea typeface="PF Centro Sans Pro"/>
-                <a:cs typeface="PF Centro Sans Pro"/>
-              </a:rPr>
-              <a:t>30 сентября 2026</a:t>
+              <a:t>+7 987 663-19-62 | 30 сентября 2026</a:t>
             </a:r>
           </a:p>
         </p:txBody>
@@ -5017,7 +5065,7 @@
           <p:cNvPr id="6" name="Rectangle 5">
             <a:extLst xmlns:a="http://schemas.openxmlformats.org/drawingml/2006/main">
               <a:ext uri="{FF2B5EF4-FFF2-40B4-BE49-F238E27FC236}">
-                <a16:creationId xmlns:a16="http://schemas.microsoft.com/office/drawing/2014/main" id="{322A8942-5A64-4CCC-89F5-B4B4C690249F}"/>
+                <a16:creationId xmlns:a16="http://schemas.microsoft.com/office/drawing/2014/main" id="{7E50DD69-0920-4926-9D66-DB662D50F8EB}"/>
               </a:ext>
             </a:extLst>
           </p:cNvPr>
@@ -5075,7 +5123,7 @@
           <p:cNvPr id="7" name="Rectangle 6">
             <a:extLst xmlns:a="http://schemas.openxmlformats.org/drawingml/2006/main">
               <a:ext uri="{FF2B5EF4-FFF2-40B4-BE49-F238E27FC236}">
-                <a16:creationId xmlns:a16="http://schemas.microsoft.com/office/drawing/2014/main" id="{FD613E4E-8343-4A7F-B703-96A3F0386D91}"/>
+                <a16:creationId xmlns:a16="http://schemas.microsoft.com/office/drawing/2014/main" id="{807E2E39-6195-4F70-96DF-19A819A247CE}"/>
               </a:ext>
             </a:extLst>
           </p:cNvPr>
@@ -5131,7 +5179,7 @@
           <p:cNvPr id="10" name="TextBox 9">
             <a:extLst xmlns:a="http://schemas.openxmlformats.org/drawingml/2006/main">
               <a:ext uri="{FF2B5EF4-FFF2-40B4-BE49-F238E27FC236}">
-                <a16:creationId xmlns:a16="http://schemas.microsoft.com/office/drawing/2014/main" id="{C75A0D06-72D3-47D3-B0E7-C1CDFB2CE0C6}"/>
+                <a16:creationId xmlns:a16="http://schemas.microsoft.com/office/drawing/2014/main" id="{6591E0F7-EEFE-4E8C-94A7-986C3D31D0F4}"/>
               </a:ext>
             </a:extLst>
           </p:cNvPr>
@@ -5393,7 +5441,7 @@
           <p:nvPr/>
         </p:nvPicPr>
         <p:blipFill>
-          <a:blip xmlns:r="http://schemas.openxmlformats.org/officeDocument/2006/relationships" xmlns:a="http://schemas.openxmlformats.org/drawingml/2006/main" r:embed="R977920ad642c4474">
+          <a:blip xmlns:r="http://schemas.openxmlformats.org/officeDocument/2006/relationships" xmlns:a="http://schemas.openxmlformats.org/drawingml/2006/main" r:embed="Rb6d901e0237c4a28">
             <a:biLevel thresh="50000"/>
           </a:blip>
           <a:stretch xmlns:a="http://schemas.openxmlformats.org/drawingml/2006/main">
@@ -5422,7 +5470,7 @@
           <p:nvPr/>
         </p:nvPicPr>
         <p:blipFill>
-          <a:blip xmlns:r="http://schemas.openxmlformats.org/officeDocument/2006/relationships" xmlns:a="http://schemas.openxmlformats.org/drawingml/2006/main" r:embed="Rfcb0da9930cb4d8d"/>
+          <a:blip xmlns:r="http://schemas.openxmlformats.org/officeDocument/2006/relationships" xmlns:a="http://schemas.openxmlformats.org/drawingml/2006/main" r:embed="R9c73d872209748a3"/>
           <a:stretch xmlns:a="http://schemas.openxmlformats.org/drawingml/2006/main">
             <a:fillRect l="0" t="0" r="0" b="0"/>
           </a:stretch>
@@ -5446,7 +5494,7 @@
           <p:nvPr/>
         </p:nvPicPr>
         <p:blipFill>
-          <a:blip xmlns:r="http://schemas.openxmlformats.org/officeDocument/2006/relationships" xmlns:a="http://schemas.openxmlformats.org/drawingml/2006/main" r:embed="R7e19f9b166154e89"/>
+          <a:blip xmlns:r="http://schemas.openxmlformats.org/officeDocument/2006/relationships" xmlns:a="http://schemas.openxmlformats.org/drawingml/2006/main" r:embed="Re87ed34a6a1a4f57"/>
           <a:stretch xmlns:a="http://schemas.openxmlformats.org/drawingml/2006/main"/>
         </p:blipFill>
         <p:spPr>
@@ -5464,7 +5512,7 @@
           <p:cNvPr id="14" name="">
             <a:extLst xmlns:a="http://schemas.openxmlformats.org/drawingml/2006/main">
               <a:ext uri="{FF2B5EF4-FFF2-40B4-BE49-F238E27FC236}">
-                <a16:creationId xmlns:a16="http://schemas.microsoft.com/office/drawing/2014/main" id="{502CF207-E369-4ECF-B1F9-66728593390A}"/>
+                <a16:creationId xmlns:a16="http://schemas.microsoft.com/office/drawing/2014/main" id="{8DEAE69A-B77C-4082-94D8-388D3E06A495}"/>
               </a:ext>
             </a:extLst>
           </p:cNvPr>
@@ -5511,7 +5559,7 @@
                 <a:ea typeface="PF Centro Sans Pro"/>
                 <a:cs typeface="PF Centro Sans Pro"/>
               </a:rPr>
-              <a:t>Рабочий интерфейс прототипа</a:t>
+              <a:t>Интерфейс программного прототипа</a:t>
             </a:r>
           </a:p>
           <a:p xmlns:a="http://schemas.openxmlformats.org/drawingml/2006/main">
@@ -5534,7 +5582,7 @@
                 <a:ea typeface="PF Centro Sans Pro"/>
                 <a:cs typeface="PF Centro Sans Pro"/>
               </a:rPr>
-              <a:t>Синтетические потоки и события</a:t>
+              <a:t>Моделируемые потоки и события</a:t>
             </a:r>
           </a:p>
         </p:txBody>
@@ -5566,7 +5614,7 @@
           <p:cNvPr id="6" name="Rectangle 5">
             <a:extLst xmlns:a="http://schemas.openxmlformats.org/drawingml/2006/main">
               <a:ext uri="{FF2B5EF4-FFF2-40B4-BE49-F238E27FC236}">
-                <a16:creationId xmlns:a16="http://schemas.microsoft.com/office/drawing/2014/main" id="{13AB4887-DA77-460E-A793-7295C862EAA8}"/>
+                <a16:creationId xmlns:a16="http://schemas.microsoft.com/office/drawing/2014/main" id="{7F71B4D7-761B-41BD-8B35-8D56C3B3C2C2}"/>
               </a:ext>
             </a:extLst>
           </p:cNvPr>
@@ -5624,7 +5672,7 @@
           <p:cNvPr id="7" name="Rectangle 6">
             <a:extLst xmlns:a="http://schemas.openxmlformats.org/drawingml/2006/main">
               <a:ext uri="{FF2B5EF4-FFF2-40B4-BE49-F238E27FC236}">
-                <a16:creationId xmlns:a16="http://schemas.microsoft.com/office/drawing/2014/main" id="{0474FF4A-CC40-4F15-B4E5-067DF8947785}"/>
+                <a16:creationId xmlns:a16="http://schemas.microsoft.com/office/drawing/2014/main" id="{73F352CB-30B2-4C27-BEF0-93FDF768A2DE}"/>
               </a:ext>
             </a:extLst>
           </p:cNvPr>
@@ -5680,7 +5728,7 @@
           <p:cNvPr id="10" name="TextBox 9">
             <a:extLst xmlns:a="http://schemas.openxmlformats.org/drawingml/2006/main">
               <a:ext uri="{FF2B5EF4-FFF2-40B4-BE49-F238E27FC236}">
-                <a16:creationId xmlns:a16="http://schemas.microsoft.com/office/drawing/2014/main" id="{48960CC8-FBB9-4F74-877C-8CC84E540A44}"/>
+                <a16:creationId xmlns:a16="http://schemas.microsoft.com/office/drawing/2014/main" id="{3B6447D1-F0C4-4792-9A80-808001D1241A}"/>
               </a:ext>
             </a:extLst>
           </p:cNvPr>
@@ -5769,7 +5817,7 @@
                 <a:ea typeface="PF Centro Sans Pro"/>
                 <a:cs typeface="PF Centro Sans Pro"/>
               </a:rPr>
-              <a:t>Финансовая гипотеза. Все суммы в млн руб., округлены.</a:t>
+              <a:t>Прогноз финансовых показателей, млн руб. (округлённо)</a:t>
             </a:r>
             <a:endParaRPr sz="1400">
               <a:latin typeface="PF Centro Sans Pro"/>
@@ -5788,7 +5836,7 @@
           <p:nvPr/>
         </p:nvPicPr>
         <p:blipFill>
-          <a:blip xmlns:r="http://schemas.openxmlformats.org/officeDocument/2006/relationships" xmlns:a="http://schemas.openxmlformats.org/drawingml/2006/main" r:embed="R5cfa2c25c20d4639"/>
+          <a:blip xmlns:r="http://schemas.openxmlformats.org/officeDocument/2006/relationships" xmlns:a="http://schemas.openxmlformats.org/drawingml/2006/main" r:embed="R3cb9ba872cb94c98"/>
           <a:stretch xmlns:a="http://schemas.openxmlformats.org/drawingml/2006/main">
             <a:fillRect l="0" t="0" r="0" b="0"/>
           </a:stretch>
@@ -6468,7 +6516,7 @@
           <p:cNvPr id="13" name="">
             <a:extLst xmlns:a="http://schemas.openxmlformats.org/drawingml/2006/main">
               <a:ext uri="{FF2B5EF4-FFF2-40B4-BE49-F238E27FC236}">
-                <a16:creationId xmlns:a16="http://schemas.microsoft.com/office/drawing/2014/main" id="{897251C9-77E5-4B1D-9ACD-BDCACB80923C}"/>
+                <a16:creationId xmlns:a16="http://schemas.microsoft.com/office/drawing/2014/main" id="{F73CB6B8-6A06-46D0-B3D0-476D6AE49936}"/>
               </a:ext>
             </a:extLst>
           </p:cNvPr>
@@ -6548,7 +6596,7 @@
           <p:cNvPr id="14" name="">
             <a:extLst xmlns:a="http://schemas.openxmlformats.org/drawingml/2006/main">
               <a:ext uri="{FF2B5EF4-FFF2-40B4-BE49-F238E27FC236}">
-                <a16:creationId xmlns:a16="http://schemas.microsoft.com/office/drawing/2014/main" id="{57338039-BB69-4F87-A248-090D1223EB0F}"/>
+                <a16:creationId xmlns:a16="http://schemas.microsoft.com/office/drawing/2014/main" id="{8C9C4D84-86DC-4A1C-ACF2-E5F5EC6EDBD2}"/>
               </a:ext>
             </a:extLst>
           </p:cNvPr>
@@ -6628,7 +6676,7 @@
           <p:cNvPr id="15" name="">
             <a:extLst xmlns:a="http://schemas.openxmlformats.org/drawingml/2006/main">
               <a:ext uri="{FF2B5EF4-FFF2-40B4-BE49-F238E27FC236}">
-                <a16:creationId xmlns:a16="http://schemas.microsoft.com/office/drawing/2014/main" id="{8213B5B4-F482-4279-B00F-F49EDA61A649}"/>
+                <a16:creationId xmlns:a16="http://schemas.microsoft.com/office/drawing/2014/main" id="{CC94AD32-A7A2-4AFF-BD86-F71D440EE327}"/>
               </a:ext>
             </a:extLst>
           </p:cNvPr>
@@ -6721,7 +6769,7 @@
                 <a:ea typeface="PF Centro Sans Pro"/>
                 <a:cs typeface="PF Centro Sans Pro"/>
               </a:rPr>
-              <a:t>Подробная модель: приложение Excel. Предзаказы и доходность не подтверждены.</a:t>
+              <a:t>Расчётная модель приведена в приложении Excel. Предзаказы и фактическая доходность отсутствуют.</a:t>
             </a:r>
           </a:p>
         </p:txBody>
@@ -6753,7 +6801,7 @@
           <p:cNvPr id="6" name="Rectangle 5">
             <a:extLst xmlns:a="http://schemas.openxmlformats.org/drawingml/2006/main">
               <a:ext uri="{FF2B5EF4-FFF2-40B4-BE49-F238E27FC236}">
-                <a16:creationId xmlns:a16="http://schemas.microsoft.com/office/drawing/2014/main" id="{DA12F8DA-B040-4715-A1BC-DC24623D3E69}"/>
+                <a16:creationId xmlns:a16="http://schemas.microsoft.com/office/drawing/2014/main" id="{45C5B4E2-A6ED-4A60-ACC5-E7715467098C}"/>
               </a:ext>
             </a:extLst>
           </p:cNvPr>
@@ -6815,7 +6863,7 @@
           <p:cNvPr id="7" name="Rectangle 6">
             <a:extLst xmlns:a="http://schemas.openxmlformats.org/drawingml/2006/main">
               <a:ext uri="{FF2B5EF4-FFF2-40B4-BE49-F238E27FC236}">
-                <a16:creationId xmlns:a16="http://schemas.microsoft.com/office/drawing/2014/main" id="{EF332156-E97A-4AA7-ACF5-26CD6F780A99}"/>
+                <a16:creationId xmlns:a16="http://schemas.microsoft.com/office/drawing/2014/main" id="{BBD1C3C1-AA07-4E51-9D27-BCB21E4242A0}"/>
               </a:ext>
             </a:extLst>
           </p:cNvPr>
@@ -6873,7 +6921,7 @@
           <p:cNvPr id="9" name="Rectangle 8">
             <a:extLst xmlns:a="http://schemas.openxmlformats.org/drawingml/2006/main">
               <a:ext uri="{FF2B5EF4-FFF2-40B4-BE49-F238E27FC236}">
-                <a16:creationId xmlns:a16="http://schemas.microsoft.com/office/drawing/2014/main" id="{CC01591C-336A-4149-83B1-C8D9AFB94BD4}"/>
+                <a16:creationId xmlns:a16="http://schemas.microsoft.com/office/drawing/2014/main" id="{3EF8EB95-F79D-47EA-B71F-33C489D85176}"/>
               </a:ext>
             </a:extLst>
           </p:cNvPr>
@@ -6935,7 +6983,7 @@
           <p:cNvPr id="10" name="TextBox 9">
             <a:extLst xmlns:a="http://schemas.openxmlformats.org/drawingml/2006/main">
               <a:ext uri="{FF2B5EF4-FFF2-40B4-BE49-F238E27FC236}">
-                <a16:creationId xmlns:a16="http://schemas.microsoft.com/office/drawing/2014/main" id="{14044D61-FD37-4CF8-A28F-B1B1D5680CFA}"/>
+                <a16:creationId xmlns:a16="http://schemas.microsoft.com/office/drawing/2014/main" id="{5EACBF7C-1905-4EE1-9096-BA10D30A1DD0}"/>
               </a:ext>
             </a:extLst>
           </p:cNvPr>
@@ -7024,7 +7072,7 @@
                 <a:ea typeface="PF Centro Sans Pro"/>
                 <a:cs typeface="PF Centro Sans Pro"/>
               </a:rPr>
-              <a:t>Риски пилота и коммерческого запуска</a:t>
+              <a:t>Риски апробации и коммерциализации</a:t>
             </a:r>
             <a:endParaRPr sz="1200">
               <a:latin typeface="Aptos"/>
@@ -7043,7 +7091,7 @@
           <p:nvPr/>
         </p:nvPicPr>
         <p:blipFill>
-          <a:blip xmlns:r="http://schemas.openxmlformats.org/officeDocument/2006/relationships" xmlns:a="http://schemas.openxmlformats.org/drawingml/2006/main" r:embed="R8bd9c07f437a4cf9"/>
+          <a:blip xmlns:r="http://schemas.openxmlformats.org/officeDocument/2006/relationships" xmlns:a="http://schemas.openxmlformats.org/drawingml/2006/main" r:embed="R817fd701a0144331"/>
           <a:stretch xmlns:a="http://schemas.openxmlformats.org/drawingml/2006/main">
             <a:fillRect l="0" t="0" r="0" b="0"/>
           </a:stretch>
@@ -7174,7 +7222,7 @@
                           <a:ea typeface="PF Centro Sans Pro"/>
                           <a:cs typeface="PF Centro Sans Pro"/>
                         </a:rPr>
-                        <a:t>Ошибки распознавания, сложные ракурсы</a:t>
+                        <a:t>Ошибки распознавания</a:t>
                       </a:r>
                     </a:p>
                   </a:txBody>
@@ -7254,7 +7302,7 @@
                           <a:ea typeface="PF Centro Sans Pro"/>
                           <a:cs typeface="PF Centro Sans Pro"/>
                         </a:rPr>
-                        <a:t>Перегрузка сервера и разрывы потока</a:t>
+                        <a:t>Перегрузка и разрывы потока</a:t>
                       </a:r>
                     </a:p>
                   </a:txBody>
@@ -7306,7 +7354,7 @@
                           <a:ea typeface="PF Centro Sans Pro"/>
                           <a:cs typeface="PF Centro Sans Pro"/>
                         </a:rPr>
-                        <a:t>Замеры, пропуск кадров, reconnect</a:t>
+                        <a:t>Контроль нагрузки, переподключение</a:t>
                       </a:r>
                     </a:p>
                   </a:txBody>
@@ -7829,7 +7877,7 @@
           <p:cNvPr id="14" name="">
             <a:extLst xmlns:a="http://schemas.openxmlformats.org/drawingml/2006/main">
               <a:ext uri="{FF2B5EF4-FFF2-40B4-BE49-F238E27FC236}">
-                <a16:creationId xmlns:a16="http://schemas.microsoft.com/office/drawing/2014/main" id="{9F894400-938A-4F28-A89F-19025C0E0C47}"/>
+                <a16:creationId xmlns:a16="http://schemas.microsoft.com/office/drawing/2014/main" id="{859F9DF2-9FF5-47AF-ADAA-348A38F45D80}"/>
               </a:ext>
             </a:extLst>
           </p:cNvPr>
@@ -8115,7 +8163,7 @@
                 <a:ea typeface="PF Centro Sans Pro"/>
                 <a:cs typeface="PF Centro Sans Pro"/>
               </a:rPr>
-              <a:t>Демонстрация на реальном видео</a:t>
+              <a:t>Результаты функциональных испытаний</a:t>
             </a:r>
             <a:endParaRPr sz="1400">
               <a:latin typeface="Times New Roman"/>
@@ -8134,7 +8182,7 @@
           <p:nvPr/>
         </p:nvPicPr>
         <p:blipFill>
-          <a:blip xmlns:r="http://schemas.openxmlformats.org/officeDocument/2006/relationships" xmlns:a="http://schemas.openxmlformats.org/drawingml/2006/main" r:embed="R809efed257074461"/>
+          <a:blip xmlns:r="http://schemas.openxmlformats.org/officeDocument/2006/relationships" xmlns:a="http://schemas.openxmlformats.org/drawingml/2006/main" r:embed="Rab0b8baf9f954b8e"/>
           <a:stretch xmlns:a="http://schemas.openxmlformats.org/drawingml/2006/main">
             <a:fillRect l="0" t="0" r="0" b="0"/>
           </a:stretch>
@@ -8158,7 +8206,7 @@
           <p:nvPr/>
         </p:nvPicPr>
         <p:blipFill>
-          <a:blip xmlns:r="http://schemas.openxmlformats.org/officeDocument/2006/relationships" xmlns:a="http://schemas.openxmlformats.org/drawingml/2006/main" r:embed="Rec1cd661b0f74082"/>
+          <a:blip xmlns:r="http://schemas.openxmlformats.org/officeDocument/2006/relationships" xmlns:a="http://schemas.openxmlformats.org/drawingml/2006/main" r:embed="Rc4df3a36bb4b411b"/>
           <a:stretch xmlns:a="http://schemas.openxmlformats.org/drawingml/2006/main"/>
         </p:blipFill>
         <p:spPr>
@@ -8176,7 +8224,7 @@
           <p:cNvPr id="13" name="">
             <a:extLst xmlns:a="http://schemas.openxmlformats.org/drawingml/2006/main">
               <a:ext uri="{FF2B5EF4-FFF2-40B4-BE49-F238E27FC236}">
-                <a16:creationId xmlns:a16="http://schemas.microsoft.com/office/drawing/2014/main" id="{19A66AB1-98A9-40E1-ABDA-0E822340D332}"/>
+                <a16:creationId xmlns:a16="http://schemas.microsoft.com/office/drawing/2014/main" id="{0DBEA58D-8BF1-4B21-A46D-AE1998B9EA2F}"/>
               </a:ext>
             </a:extLst>
           </p:cNvPr>
@@ -8246,7 +8294,7 @@
                 <a:ea typeface="PF Centro Sans Pro"/>
                 <a:cs typeface="PF Centro Sans Pro"/>
               </a:rPr>
-              <a:t>15,8 с видео, 127 кадров,</a:t>
+              <a:t>Видео: 15,8 с; 127 кадров.</a:t>
             </a:r>
           </a:p>
           <a:p xmlns:a="http://schemas.openxmlformats.org/drawingml/2006/main">
@@ -8269,7 +8317,7 @@
                 <a:ea typeface="PF Centro Sans Pro"/>
                 <a:cs typeface="PF Centro Sans Pro"/>
               </a:rPr>
-              <a:t>два ID треков.</a:t>
+              <a:t>Зарегистрированы 2 трека.</a:t>
             </a:r>
           </a:p>
           <a:p xmlns:a="http://schemas.openxmlformats.org/drawingml/2006/main">
@@ -8297,7 +8345,7 @@
                 <a:ea typeface="PF Centro Sans Pro"/>
                 <a:cs typeface="PF Centro Sans Pro"/>
               </a:rPr>
-              <a:t>Проверка на COCO8</a:t>
+              <a:t>Функциональная проверка COCO8</a:t>
             </a:r>
           </a:p>
           <a:p xmlns:a="http://schemas.openxmlformats.org/drawingml/2006/main">
@@ -8320,7 +8368,7 @@
                 <a:ea typeface="PF Centro Sans Pro"/>
                 <a:cs typeface="PF Centro Sans Pro"/>
               </a:rPr>
-              <a:t>8 фото, найдены 4 из 10</a:t>
+              <a:t>8 изображений, 10 людей.</a:t>
             </a:r>
           </a:p>
           <a:p xmlns:a="http://schemas.openxmlformats.org/drawingml/2006/main">
@@ -8343,7 +8391,7 @@
                 <a:ea typeface="PF Centro Sans Pro"/>
                 <a:cs typeface="PF Centro Sans Pro"/>
               </a:rPr>
-              <a:t>людей, лишних — 0.</a:t>
+              <a:t>TP = 4; FP = 0; FN = 6.</a:t>
             </a:r>
           </a:p>
           <a:p xmlns:a="http://schemas.openxmlformats.org/drawingml/2006/main">
@@ -8371,7 +8419,7 @@
                 <a:ea typeface="PF Centro Sans Pro"/>
                 <a:cs typeface="PF Centro Sans Pro"/>
               </a:rPr>
-              <a:t>Проверки программы</a:t>
+              <a:t>Верификация программного кода</a:t>
             </a:r>
           </a:p>
           <a:p xmlns:a="http://schemas.openxmlformats.org/drawingml/2006/main">
@@ -8394,7 +8442,7 @@
                 <a:ea typeface="PF Centro Sans Pro"/>
                 <a:cs typeface="PF Centro Sans Pro"/>
               </a:rPr>
-              <a:t>39 Python-тестов и</a:t>
+              <a:t>39 тестов Python и</a:t>
             </a:r>
           </a:p>
           <a:p xmlns:a="http://schemas.openxmlformats.org/drawingml/2006/main">
@@ -8440,7 +8488,7 @@
                 <a:ea typeface="PF Centro Sans Pro"/>
                 <a:cs typeface="PF Centro Sans Pro"/>
               </a:rPr>
-              <a:t>Сборка frontend успешна.</a:t>
+              <a:t>Сборка интерфейса выполнена.</a:t>
             </a:r>
           </a:p>
         </p:txBody>
@@ -8450,7 +8498,7 @@
           <p:cNvPr id="14" name="">
             <a:extLst xmlns:a="http://schemas.openxmlformats.org/drawingml/2006/main">
               <a:ext uri="{FF2B5EF4-FFF2-40B4-BE49-F238E27FC236}">
-                <a16:creationId xmlns:a16="http://schemas.microsoft.com/office/drawing/2014/main" id="{609673D0-2D58-4FB8-B70B-C5AD6D8CC31E}"/>
+                <a16:creationId xmlns:a16="http://schemas.microsoft.com/office/drawing/2014/main" id="{D2F08165-26A2-438F-BE6E-02A4562413D3}"/>
               </a:ext>
             </a:extLst>
           </p:cNvPr>
@@ -8497,7 +8545,7 @@
                 <a:ea typeface="PF Centro Sans Pro"/>
                 <a:cs typeface="PF Centro Sans Pro"/>
               </a:rPr>
-              <a:t>Видео: сохранённый реальный инференс; СИЗ и опасные зоны не оцениваются.</a:t>
+              <a:t>Видео содержит сохранённые результаты инференса; СИЗ и опасные зоны не оценивались.</a:t>
             </a:r>
           </a:p>
           <a:p xmlns:a="http://schemas.openxmlformats.org/drawingml/2006/main">
@@ -8520,7 +8568,7 @@
                 <a:ea typeface="PF Centro Sans Pro"/>
                 <a:cs typeface="PF Centro Sans Pro"/>
               </a:rPr>
-              <a:t>COCO8 может пересекаться с обучением — это не независимая оценка точности.</a:t>
+              <a:t>COCO8 допускает пересечение с обучающей выборкой; независимая оценка качества не проведена.</a:t>
             </a:r>
           </a:p>
           <a:p xmlns:a="http://schemas.openxmlformats.org/drawingml/2006/main">
@@ -8543,7 +8591,7 @@
                 <a:ea typeface="PF Centro Sans Pro"/>
                 <a:cs typeface="PF Centro Sans Pro"/>
               </a:rPr>
-              <a:t>Промышленный пилот и предзаказы пока отсутствуют.</a:t>
+              <a:t>Промышленная апробация и подтверждённые предзаказы отсутствуют.</a:t>
             </a:r>
           </a:p>
         </p:txBody>
@@ -8575,7 +8623,7 @@
           <p:cNvPr id="7" name="Rectangle 6">
             <a:extLst xmlns:a="http://schemas.openxmlformats.org/drawingml/2006/main">
               <a:ext uri="{FF2B5EF4-FFF2-40B4-BE49-F238E27FC236}">
-                <a16:creationId xmlns:a16="http://schemas.microsoft.com/office/drawing/2014/main" id="{21A5036A-A076-4A7A-BC34-8E52943DE8F2}"/>
+                <a16:creationId xmlns:a16="http://schemas.microsoft.com/office/drawing/2014/main" id="{7856441A-BAA8-43A1-B8FE-7799F37D33D2}"/>
               </a:ext>
             </a:extLst>
           </p:cNvPr>
@@ -8631,7 +8679,7 @@
           <p:cNvPr id="10" name="TextBox 9">
             <a:extLst xmlns:a="http://schemas.openxmlformats.org/drawingml/2006/main">
               <a:ext uri="{FF2B5EF4-FFF2-40B4-BE49-F238E27FC236}">
-                <a16:creationId xmlns:a16="http://schemas.microsoft.com/office/drawing/2014/main" id="{70655DE7-F390-46AF-BDEB-AB7D1CB21CB0}"/>
+                <a16:creationId xmlns:a16="http://schemas.microsoft.com/office/drawing/2014/main" id="{2188468E-8C74-4801-8CB1-FE9D537F19BF}"/>
               </a:ext>
             </a:extLst>
           </p:cNvPr>
@@ -8732,7 +8780,7 @@
                 <a:ea typeface="PF Centro Sans Pro"/>
                 <a:cs typeface="PF Centro Sans Pro"/>
               </a:rPr>
-              <a:t>Павлов Иван Владимирович, инициатор проекта</a:t>
+              <a:t>Команда: Павлов Иван Владимирович и Фролов Денис</a:t>
             </a:r>
             <a:endParaRPr sz="1600">
               <a:solidFill>
@@ -8779,7 +8827,7 @@
                 <a:ea typeface="PF Centro Sans Pro"/>
                 <a:cs typeface="PF Centro Sans Pro"/>
               </a:rPr>
-              <a:t>ivanp246459@gmail.com   +7 987 663-19-62</a:t>
+              <a:t>Контактное лицо: ivanp246459@gmail.com   +7 987 663-19-62</a:t>
             </a:r>
           </a:p>
           <a:p xmlns:a="http://schemas.openxmlformats.org/drawingml/2006/main">
@@ -8815,7 +8863,7 @@
                 <a:ea typeface="PF Centro Sans Pro"/>
                 <a:cs typeface="PF Centro Sans Pro"/>
               </a:rPr>
-              <a:t>Состав ниже разделяет указанного участника и планируемые роли.</a:t>
+              <a:t>Действующие участники и планируемые направления привлечения специалистов</a:t>
             </a:r>
             <a:endParaRPr sz="1400">
               <a:solidFill>
@@ -9343,10 +9391,23 @@
                           <a:ea typeface="PF Centro Sans Pro"/>
                           <a:cs typeface="PF Centro Sans Pro"/>
                         </a:rPr>
-                        <a:t>Предстоит</a:t>
+                        <a:t>Фролов Денис</a:t>
                       </a:r>
                       <a:endParaRPr/>
                     </a:p>
+                  </a:txBody>
+                  <a:tcPr marL="91440" marR="91440" marT="45720" marB="45720">
+                    <a:solidFill>
+                      <a:srgbClr val="F1F5FA"/>
+                    </a:solidFill>
+                  </a:tcPr>
+                </a:tc>
+                <a:tc>
+                  <a:txBody>
+                    <a:bodyPr>
+                      <a:noAutofit/>
+                    </a:bodyPr>
+                    <a:lstStyle/>
                     <a:p>
                       <a:r>
                         <a:rPr sz="1350" b="0">
@@ -9357,10 +9418,24 @@
                           <a:ea typeface="PF Centro Sans Pro"/>
                           <a:cs typeface="PF Centro Sans Pro"/>
                         </a:rPr>
-                        <a:t>привлечь</a:t>
+                        <a:t>Разработчик</a:t>
                       </a:r>
                       <a:endParaRPr/>
                     </a:p>
+                    <a:p>
+                      <a:r>
+                        <a:rPr sz="1350" b="0">
+                          <a:solidFill>
+                            <a:srgbClr val="222C38"/>
+                          </a:solidFill>
+                          <a:latin typeface="PF Centro Sans Pro"/>
+                          <a:ea typeface="PF Centro Sans Pro"/>
+                          <a:cs typeface="PF Centro Sans Pro"/>
+                        </a:rPr>
+                        <a:t>платформы</a:t>
+                      </a:r>
+                      <a:endParaRPr/>
+                    </a:p>
                   </a:txBody>
                   <a:tcPr marL="91440" marR="91440" marT="45720" marB="45720">
                     <a:solidFill>
@@ -9384,10 +9459,24 @@
                           <a:ea typeface="PF Centro Sans Pro"/>
                           <a:cs typeface="PF Centro Sans Pro"/>
                         </a:rPr>
-                        <a:t>ML-инженер</a:t>
+                        <a:t>Разработка</a:t>
                       </a:r>
                       <a:endParaRPr/>
                     </a:p>
+                    <a:p>
+                      <a:r>
+                        <a:rPr sz="1350" b="0">
+                          <a:solidFill>
+                            <a:srgbClr val="222C38"/>
+                          </a:solidFill>
+                          <a:latin typeface="PF Centro Sans Pro"/>
+                          <a:ea typeface="PF Centro Sans Pro"/>
+                          <a:cs typeface="PF Centro Sans Pro"/>
+                        </a:rPr>
+                        <a:t>платформы</a:t>
+                      </a:r>
+                      <a:endParaRPr/>
+                    </a:p>
                   </a:txBody>
                   <a:tcPr marL="91440" marR="91440" marT="45720" marB="45720">
                     <a:solidFill>
@@ -9411,10 +9500,23 @@
                           <a:ea typeface="PF Centro Sans Pro"/>
                           <a:cs typeface="PF Centro Sans Pro"/>
                         </a:rPr>
-                        <a:t>Модели и</a:t>
+                        <a:t>Не указан</a:t>
                       </a:r>
                       <a:endParaRPr/>
                     </a:p>
+                  </a:txBody>
+                  <a:tcPr marL="91440" marR="91440" marT="45720" marB="45720">
+                    <a:solidFill>
+                      <a:srgbClr val="F1F5FA"/>
+                    </a:solidFill>
+                  </a:tcPr>
+                </a:tc>
+                <a:tc>
+                  <a:txBody>
+                    <a:bodyPr>
+                      <a:noAutofit/>
+                    </a:bodyPr>
+                    <a:lstStyle/>
                     <a:p>
                       <a:r>
                         <a:rPr sz="1350" b="0">
@@ -9425,10 +9527,24 @@
                           <a:ea typeface="PF Centro Sans Pro"/>
                           <a:cs typeface="PF Centro Sans Pro"/>
                         </a:rPr>
-                        <a:t>оценка качества</a:t>
+                        <a:t>Программная</a:t>
                       </a:r>
                       <a:endParaRPr/>
                     </a:p>
+                    <a:p>
+                      <a:r>
+                        <a:rPr sz="1350" b="0">
+                          <a:solidFill>
+                            <a:srgbClr val="222C38"/>
+                          </a:solidFill>
+                          <a:latin typeface="PF Centro Sans Pro"/>
+                          <a:ea typeface="PF Centro Sans Pro"/>
+                          <a:cs typeface="PF Centro Sans Pro"/>
+                        </a:rPr>
+                        <a:t>платформа</a:t>
+                      </a:r>
+                      <a:endParaRPr/>
+                    </a:p>
                   </a:txBody>
                   <a:tcPr marL="91440" marR="91440" marT="45720" marB="45720">
                     <a:solidFill>
@@ -9452,75 +9568,7 @@
                           <a:ea typeface="PF Centro Sans Pro"/>
                           <a:cs typeface="PF Centro Sans Pro"/>
                         </a:rPr>
-                        <a:t>Подбор</a:t>
-                      </a:r>
-                      <a:endParaRPr/>
-                    </a:p>
-                  </a:txBody>
-                  <a:tcPr marL="91440" marR="91440" marT="45720" marB="45720">
-                    <a:solidFill>
-                      <a:srgbClr val="F1F5FA"/>
-                    </a:solidFill>
-                  </a:tcPr>
-                </a:tc>
-                <a:tc>
-                  <a:txBody>
-                    <a:bodyPr>
-                      <a:noAutofit/>
-                    </a:bodyPr>
-                    <a:lstStyle/>
-                    <a:p>
-                      <a:r>
-                        <a:rPr sz="1350" b="0">
-                          <a:solidFill>
-                            <a:srgbClr val="222C38"/>
-                          </a:solidFill>
-                          <a:latin typeface="PF Centro Sans Pro"/>
-                          <a:ea typeface="PF Centro Sans Pro"/>
-                          <a:cs typeface="PF Centro Sans Pro"/>
-                        </a:rPr>
-                        <a:t>Обучение и</a:t>
-                      </a:r>
-                      <a:endParaRPr/>
-                    </a:p>
-                    <a:p>
-                      <a:r>
-                        <a:rPr sz="1350" b="0">
-                          <a:solidFill>
-                            <a:srgbClr val="222C38"/>
-                          </a:solidFill>
-                          <a:latin typeface="PF Centro Sans Pro"/>
-                          <a:ea typeface="PF Centro Sans Pro"/>
-                          <a:cs typeface="PF Centro Sans Pro"/>
-                        </a:rPr>
-                        <a:t>проверка моделей</a:t>
-                      </a:r>
-                      <a:endParaRPr/>
-                    </a:p>
-                  </a:txBody>
-                  <a:tcPr marL="91440" marR="91440" marT="45720" marB="45720">
-                    <a:solidFill>
-                      <a:srgbClr val="F1F5FA"/>
-                    </a:solidFill>
-                  </a:tcPr>
-                </a:tc>
-                <a:tc>
-                  <a:txBody>
-                    <a:bodyPr>
-                      <a:noAutofit/>
-                    </a:bodyPr>
-                    <a:lstStyle/>
-                    <a:p>
-                      <a:r>
-                        <a:rPr sz="1350" b="0">
-                          <a:solidFill>
-                            <a:srgbClr val="222C38"/>
-                          </a:solidFill>
-                          <a:latin typeface="PF Centro Sans Pro"/>
-                          <a:ea typeface="PF Centro Sans Pro"/>
-                          <a:cs typeface="PF Centro Sans Pro"/>
-                        </a:rPr>
-                        <a:t>План</a:t>
+                        <a:t>Участник</a:t>
                       </a:r>
                       <a:endParaRPr/>
                     </a:p>
@@ -9576,7 +9624,7 @@
                           <a:ea typeface="PF Centro Sans Pro"/>
                           <a:cs typeface="PF Centro Sans Pro"/>
                         </a:rPr>
-                        <a:t>Предстоит</a:t>
+                        <a:t>Планируется</a:t>
                       </a:r>
                       <a:endParaRPr/>
                     </a:p>
@@ -9590,7 +9638,7 @@
                           <a:ea typeface="PF Centro Sans Pro"/>
                           <a:cs typeface="PF Centro Sans Pro"/>
                         </a:rPr>
-                        <a:t>привлечь</a:t>
+                        <a:t>привлечение</a:t>
                       </a:r>
                       <a:endParaRPr/>
                     </a:p>
@@ -9617,7 +9665,7 @@
                           <a:ea typeface="PF Centro Sans Pro"/>
                           <a:cs typeface="PF Centro Sans Pro"/>
                         </a:rPr>
-                        <a:t>Разработчик</a:t>
+                        <a:t>ML-инженер</a:t>
                       </a:r>
                       <a:endParaRPr/>
                     </a:p>
@@ -9644,7 +9692,7 @@
                           <a:ea typeface="PF Centro Sans Pro"/>
                           <a:cs typeface="PF Centro Sans Pro"/>
                         </a:rPr>
-                        <a:t>Платформа и</a:t>
+                        <a:t>Модели и</a:t>
                       </a:r>
                       <a:endParaRPr/>
                     </a:p>
@@ -9658,7 +9706,7 @@
                           <a:ea typeface="PF Centro Sans Pro"/>
                           <a:cs typeface="PF Centro Sans Pro"/>
                         </a:rPr>
-                        <a:t>интеграция</a:t>
+                        <a:t>оценка качества</a:t>
                       </a:r>
                       <a:endParaRPr/>
                     </a:p>
@@ -9712,7 +9760,7 @@
                           <a:ea typeface="PF Centro Sans Pro"/>
                           <a:cs typeface="PF Centro Sans Pro"/>
                         </a:rPr>
-                        <a:t>Подготовка</a:t>
+                        <a:t>Обучение и</a:t>
                       </a:r>
                       <a:endParaRPr/>
                     </a:p>
@@ -9726,7 +9774,7 @@
                           <a:ea typeface="PF Centro Sans Pro"/>
                           <a:cs typeface="PF Centro Sans Pro"/>
                         </a:rPr>
-                        <a:t>к пилоту</a:t>
+                        <a:t>проверка моделей</a:t>
                       </a:r>
                       <a:endParaRPr/>
                     </a:p>
@@ -10258,7 +10306,7 @@
           <p:nvPr/>
         </p:nvPicPr>
         <p:blipFill>
-          <a:blip xmlns:r="http://schemas.openxmlformats.org/officeDocument/2006/relationships" xmlns:a="http://schemas.openxmlformats.org/drawingml/2006/main" r:embed="R7a7929b7f4714388"/>
+          <a:blip xmlns:r="http://schemas.openxmlformats.org/officeDocument/2006/relationships" xmlns:a="http://schemas.openxmlformats.org/drawingml/2006/main" r:embed="Rf8bd709f1ab049a2"/>
           <a:stretch xmlns:a="http://schemas.openxmlformats.org/drawingml/2006/main">
             <a:fillRect l="0" t="0" r="0" b="0"/>
           </a:stretch>
@@ -10300,7 +10348,7 @@
           <p:cNvPr id="7" name="Rectangle 6">
             <a:extLst xmlns:a="http://schemas.openxmlformats.org/drawingml/2006/main">
               <a:ext uri="{FF2B5EF4-FFF2-40B4-BE49-F238E27FC236}">
-                <a16:creationId xmlns:a16="http://schemas.microsoft.com/office/drawing/2014/main" id="{EA4890FF-8718-4383-B34F-4E39574FC992}"/>
+                <a16:creationId xmlns:a16="http://schemas.microsoft.com/office/drawing/2014/main" id="{30860F7D-0189-4634-9CA6-0F205531C6BF}"/>
               </a:ext>
             </a:extLst>
           </p:cNvPr>
@@ -10356,7 +10404,7 @@
           <p:cNvPr id="10" name="TextBox 9">
             <a:extLst xmlns:a="http://schemas.openxmlformats.org/drawingml/2006/main">
               <a:ext uri="{FF2B5EF4-FFF2-40B4-BE49-F238E27FC236}">
-                <a16:creationId xmlns:a16="http://schemas.microsoft.com/office/drawing/2014/main" id="{64004583-9AAD-4887-8A3C-08BE122C1308}"/>
+                <a16:creationId xmlns:a16="http://schemas.microsoft.com/office/drawing/2014/main" id="{AE7B2131-EAD8-433C-A905-D46C84D61708}"/>
               </a:ext>
             </a:extLst>
           </p:cNvPr>
@@ -10404,7 +10452,7 @@
           <p:nvPr/>
         </p:nvPicPr>
         <p:blipFill>
-          <a:blip xmlns:r="http://schemas.openxmlformats.org/officeDocument/2006/relationships" xmlns:a="http://schemas.openxmlformats.org/drawingml/2006/main" r:embed="R7c5b147335644dff"/>
+          <a:blip xmlns:r="http://schemas.openxmlformats.org/officeDocument/2006/relationships" xmlns:a="http://schemas.openxmlformats.org/drawingml/2006/main" r:embed="R7cbde368816c4d2a"/>
           <a:stretch xmlns:a="http://schemas.openxmlformats.org/drawingml/2006/main">
             <a:fillRect l="0" t="0" r="0" b="0"/>
           </a:stretch>
@@ -10424,7 +10472,7 @@
           <p:cNvPr id="12" name="">
             <a:extLst xmlns:a="http://schemas.openxmlformats.org/drawingml/2006/main">
               <a:ext uri="{FF2B5EF4-FFF2-40B4-BE49-F238E27FC236}">
-                <a16:creationId xmlns:a16="http://schemas.microsoft.com/office/drawing/2014/main" id="{F3D2681F-BCCF-4461-8855-393C301B696A}"/>
+                <a16:creationId xmlns:a16="http://schemas.microsoft.com/office/drawing/2014/main" id="{C8D6CD0A-323C-479F-BAE6-06D311D9D67E}"/>
               </a:ext>
             </a:extLst>
           </p:cNvPr>
@@ -10471,7 +10519,7 @@
                 <a:ea typeface="PF Centro Sans Pro"/>
                 <a:cs typeface="PF Centro Sans Pro"/>
               </a:rPr>
-              <a:t>Запрос к промышленному партнёру</a:t>
+              <a:t>Условия промышленной апробации</a:t>
             </a:r>
           </a:p>
         </p:txBody>
@@ -10481,7 +10529,7 @@
           <p:cNvPr id="13" name="">
             <a:extLst xmlns:a="http://schemas.openxmlformats.org/drawingml/2006/main">
               <a:ext uri="{FF2B5EF4-FFF2-40B4-BE49-F238E27FC236}">
-                <a16:creationId xmlns:a16="http://schemas.microsoft.com/office/drawing/2014/main" id="{E2677DEB-0233-456A-9BE9-1E59A999B2B9}"/>
+                <a16:creationId xmlns:a16="http://schemas.microsoft.com/office/drawing/2014/main" id="{8B629BA6-B685-464E-852E-F716232810B5}"/>
               </a:ext>
             </a:extLst>
           </p:cNvPr>
@@ -10528,7 +10576,7 @@
                 <a:ea typeface="PF Centro Sans Pro"/>
                 <a:cs typeface="PF Centro Sans Pro"/>
               </a:rPr>
-              <a:t>Площадка для пилота на 1–2 участках, видеозаписи для разрешённого обучения и тестирования, эксперт охраны труда и согласованные критерии приёмки.</a:t>
+              <a:t>Для испытаний необходимы 1–2 производственных участка, правомерный доступ к видеоданным, участие эксперта охраны труда и согласованные критерии приёмки.</a:t>
             </a:r>
           </a:p>
         </p:txBody>
@@ -10538,7 +10586,7 @@
           <p:cNvPr id="14" name="">
             <a:extLst xmlns:a="http://schemas.openxmlformats.org/drawingml/2006/main">
               <a:ext uri="{FF2B5EF4-FFF2-40B4-BE49-F238E27FC236}">
-                <a16:creationId xmlns:a16="http://schemas.microsoft.com/office/drawing/2014/main" id="{EFD0366A-6A13-4B83-9174-BBC194ECFB8F}"/>
+                <a16:creationId xmlns:a16="http://schemas.microsoft.com/office/drawing/2014/main" id="{D451D055-2C7D-4DAC-853E-7D6DBD4505B1}"/>
               </a:ext>
             </a:extLst>
           </p:cNvPr>
@@ -10585,7 +10633,7 @@
                 <a:ea typeface="PF Centro Sans Pro"/>
                 <a:cs typeface="PF Centro Sans Pro"/>
               </a:rPr>
-              <a:t>Что измерим на пилоте</a:t>
+              <a:t>Показатели и методика оценки</a:t>
             </a:r>
           </a:p>
         </p:txBody>
@@ -10595,7 +10643,7 @@
           <p:cNvPr id="15" name="">
             <a:extLst xmlns:a="http://schemas.openxmlformats.org/drawingml/2006/main">
               <a:ext uri="{FF2B5EF4-FFF2-40B4-BE49-F238E27FC236}">
-                <a16:creationId xmlns:a16="http://schemas.microsoft.com/office/drawing/2014/main" id="{FAE1ACC1-6C02-4DC4-8C8A-93E3ED3ED13D}"/>
+                <a16:creationId xmlns:a16="http://schemas.microsoft.com/office/drawing/2014/main" id="{D359C14F-16BC-42AE-BCAA-911F285C8138}"/>
               </a:ext>
             </a:extLst>
           </p:cNvPr>
@@ -10642,7 +10690,7 @@
                 <a:ea typeface="PF Centro Sans Pro"/>
                 <a:cs typeface="PF Centro Sans Pro"/>
               </a:rPr>
-              <a:t>Precision / recall по видам нарушений, ложные тревоги на камеру-час, задержку p95, доступность потоков, время оператора на разбор и стоимость канала.</a:t>
+              <a:t>Точность и полнота выявления нарушений; ложные тревоги на камеру-час; задержка p95; доступность потоков; трудозатраты оператора и стоимость канала.</a:t>
             </a:r>
           </a:p>
         </p:txBody>
@@ -10652,7 +10700,7 @@
           <p:cNvPr id="16" name="">
             <a:extLst xmlns:a="http://schemas.openxmlformats.org/drawingml/2006/main">
               <a:ext uri="{FF2B5EF4-FFF2-40B4-BE49-F238E27FC236}">
-                <a16:creationId xmlns:a16="http://schemas.microsoft.com/office/drawing/2014/main" id="{EAF50C55-F311-4997-BA41-547F0B92A2BE}"/>
+                <a16:creationId xmlns:a16="http://schemas.microsoft.com/office/drawing/2014/main" id="{17951CAC-0152-447B-99AD-66682B19F11E}"/>
               </a:ext>
             </a:extLst>
           </p:cNvPr>
@@ -10732,7 +10780,7 @@
           <p:cNvPr id="17" name="">
             <a:extLst xmlns:a="http://schemas.openxmlformats.org/drawingml/2006/main">
               <a:ext uri="{FF2B5EF4-FFF2-40B4-BE49-F238E27FC236}">
-                <a16:creationId xmlns:a16="http://schemas.microsoft.com/office/drawing/2014/main" id="{A32DC685-D87F-4078-817C-39927AE80B45}"/>
+                <a16:creationId xmlns:a16="http://schemas.microsoft.com/office/drawing/2014/main" id="{97EFC9A4-CCB2-48A2-9964-0843041B0B5E}"/>
               </a:ext>
             </a:extLst>
           </p:cNvPr>
@@ -10779,7 +10827,7 @@
                 <a:ea typeface="PF Centro Sans Pro"/>
                 <a:cs typeface="PF Centro Sans Pro"/>
               </a:rPr>
-              <a:t>Снижение травматизма, точность 99% и экономия 70% пока не подтверждены.</a:t>
+              <a:t>Влияние на травматизм и экономический эффект подлежат экспериментальной оценке.</a:t>
             </a:r>
           </a:p>
           <a:p xmlns:a="http://schemas.openxmlformats.org/drawingml/2006/main">
@@ -10802,7 +10850,7 @@
                 <a:ea typeface="PF Centro Sans Pro"/>
                 <a:cs typeface="PF Centro Sans Pro"/>
               </a:rPr>
-              <a:t>Обработка в закрытом контуре не означает автоматического соответствия всем требованиям ИБ.</a:t>
+              <a:t>Соответствие требованиям ИБ устанавливается по результатам отдельной проверки.</a:t>
             </a:r>
           </a:p>
         </p:txBody>
@@ -10834,7 +10882,7 @@
           <p:cNvPr id="6" name="Rectangle 5">
             <a:extLst xmlns:a="http://schemas.openxmlformats.org/drawingml/2006/main">
               <a:ext uri="{FF2B5EF4-FFF2-40B4-BE49-F238E27FC236}">
-                <a16:creationId xmlns:a16="http://schemas.microsoft.com/office/drawing/2014/main" id="{6A57723B-34E9-4FA8-B1A3-AD287D59FCA8}"/>
+                <a16:creationId xmlns:a16="http://schemas.microsoft.com/office/drawing/2014/main" id="{7E553BD5-55A6-4781-A6B3-6E09B1BE0FB5}"/>
               </a:ext>
             </a:extLst>
           </p:cNvPr>
@@ -10892,7 +10940,7 @@
           <p:cNvPr id="7" name="Rectangle 6">
             <a:extLst xmlns:a="http://schemas.openxmlformats.org/drawingml/2006/main">
               <a:ext uri="{FF2B5EF4-FFF2-40B4-BE49-F238E27FC236}">
-                <a16:creationId xmlns:a16="http://schemas.microsoft.com/office/drawing/2014/main" id="{05B401FE-5177-4A4A-86C4-E7336593FD0B}"/>
+                <a16:creationId xmlns:a16="http://schemas.microsoft.com/office/drawing/2014/main" id="{A538F1D7-B17C-4C82-A610-3E6633D3A73B}"/>
               </a:ext>
             </a:extLst>
           </p:cNvPr>
@@ -10948,7 +10996,7 @@
           <p:cNvPr id="10" name="TextBox 9">
             <a:extLst xmlns:a="http://schemas.openxmlformats.org/drawingml/2006/main">
               <a:ext uri="{FF2B5EF4-FFF2-40B4-BE49-F238E27FC236}">
-                <a16:creationId xmlns:a16="http://schemas.microsoft.com/office/drawing/2014/main" id="{3F2B0F31-35F1-4223-83B0-B5E26A6550E4}"/>
+                <a16:creationId xmlns:a16="http://schemas.microsoft.com/office/drawing/2014/main" id="{7C60390D-C1AF-4879-974C-662577E0F4EA}"/>
               </a:ext>
             </a:extLst>
           </p:cNvPr>
@@ -11036,7 +11084,7 @@
                 <a:ea typeface="PF Centro Sans Pro"/>
                 <a:cs typeface="PF Centro Sans Pro"/>
               </a:rPr>
-              <a:t>Локальная видеоаналитика охраны труда. Первый сценарий: вход человека в опасную зону, единый инцидент и материал для разбора оператором.</a:t>
+              <a:t>Назначение: автоматизированный контроль охраны труда по видеоданным. Базовый сценарий: регистрация присутствия человека в опасной зоне с агрегацией событий в инцидент.</a:t>
             </a:r>
             <a:endParaRPr/>
           </a:p>
@@ -11071,7 +11119,7 @@
                 <a:ea typeface="PF Centro Sans Pro"/>
                 <a:cs typeface="PF Centro Sans Pro"/>
               </a:rPr>
-              <a:t>Цель ближайшего этапа: пилот на 1–2 участках с измерением ошибок, задержки и времени разбора событий.</a:t>
+              <a:t>Цель апробации: испытания на 1–2 участках с оценкой ошибок, задержки обработки и трудозатрат оператора.</a:t>
             </a:r>
           </a:p>
           <a:p xmlns:a="http://schemas.openxmlformats.org/drawingml/2006/main">
@@ -11108,7 +11156,7 @@
                 <a:ea typeface="PF Centro Sans Pro"/>
                 <a:cs typeface="PF Centro Sans Pro"/>
               </a:rPr>
-              <a:t>Готовность: рабочий прототип, подключённый YOLO11n и протокол проверки на фотографиях. Модели СИЗ и испытания на предприятии предстоят.</a:t>
+              <a:t>Стадия: программный прототип с YOLO11n; выполнены функциональные проверки на изображениях и видео. Промышленные испытания запланированы.</a:t>
             </a:r>
           </a:p>
         </p:txBody>
@@ -11122,7 +11170,7 @@
           <p:nvPr/>
         </p:nvPicPr>
         <p:blipFill>
-          <a:blip xmlns:r="http://schemas.openxmlformats.org/officeDocument/2006/relationships" xmlns:a="http://schemas.openxmlformats.org/drawingml/2006/main" r:embed="Rb5eb9cb5af104c5b"/>
+          <a:blip xmlns:r="http://schemas.openxmlformats.org/officeDocument/2006/relationships" xmlns:a="http://schemas.openxmlformats.org/drawingml/2006/main" r:embed="R6b7edbc4696e47bb"/>
           <a:stretch xmlns:a="http://schemas.openxmlformats.org/drawingml/2006/main">
             <a:fillRect l="0" t="0" r="0" b="0"/>
           </a:stretch>
@@ -11172,7 +11220,7 @@
                           <a:ea typeface="PF Centro Sans Pro"/>
                           <a:cs typeface="PF Centro Sans Pro"/>
                         </a:rPr>
-                        <a:t>Финансовая гипотеза на 3 года</a:t>
+                        <a:t>Расчётные показатели на 3 года</a:t>
                       </a:r>
                     </a:p>
                   </a:txBody>
@@ -11380,7 +11428,7 @@
           <p:cNvPr id="13" name="">
             <a:extLst xmlns:a="http://schemas.openxmlformats.org/drawingml/2006/main">
               <a:ext uri="{FF2B5EF4-FFF2-40B4-BE49-F238E27FC236}">
-                <a16:creationId xmlns:a16="http://schemas.microsoft.com/office/drawing/2014/main" id="{628ED674-9AD0-4438-B89A-9EF52B1A10B0}"/>
+                <a16:creationId xmlns:a16="http://schemas.microsoft.com/office/drawing/2014/main" id="{9F6F65A6-6259-4F5C-8269-E6DAAB1C7405}"/>
               </a:ext>
             </a:extLst>
           </p:cNvPr>
@@ -11427,7 +11475,7 @@
                 <a:ea typeface="PF Centro Sans Pro"/>
                 <a:cs typeface="PF Centro Sans Pro"/>
               </a:rPr>
-              <a:t>Расчётный сценарий, не подтверждённый спрос. Допущения и чувствительность: слайды 6, 10, 11.</a:t>
+              <a:t>Показатели основаны на прогнозе продаж. Допущения и анализ чувствительности: слайды 6, 10, 11.</a:t>
             </a:r>
           </a:p>
         </p:txBody>
@@ -11661,7 +11709,7 @@
                 <a:ea typeface="PF Centro Sans Pro"/>
                 <a:cs typeface="PF Centro Sans Pro"/>
               </a:rPr>
-              <a:t>Задача предприятия: замечать устойчивые нарушения и быстро передавать их ответственному сотруднику.</a:t>
+              <a:t>Задача: выявление устойчивых нарушений правил охраны труда и передача событий ответственному специалисту.</a:t>
             </a:r>
           </a:p>
         </p:txBody>
@@ -11675,7 +11723,7 @@
           <p:nvPr/>
         </p:nvPicPr>
         <p:blipFill>
-          <a:blip xmlns:r="http://schemas.openxmlformats.org/officeDocument/2006/relationships" xmlns:a="http://schemas.openxmlformats.org/drawingml/2006/main" r:embed="R994dd5724ca44775"/>
+          <a:blip xmlns:r="http://schemas.openxmlformats.org/officeDocument/2006/relationships" xmlns:a="http://schemas.openxmlformats.org/drawingml/2006/main" r:embed="Rf93ecaccab6541e9"/>
           <a:stretch xmlns:a="http://schemas.openxmlformats.org/drawingml/2006/main">
             <a:fillRect l="0" t="0" r="0" b="0"/>
           </a:stretch>
@@ -11726,7 +11774,7 @@
                           <a:ea typeface="PF Centro Sans Pro"/>
                           <a:cs typeface="PF Centro Sans Pro"/>
                         </a:rPr>
-                        <a:t>Текущий подход</a:t>
+                        <a:t>Метод контроля</a:t>
                       </a:r>
                     </a:p>
                   </a:txBody>
@@ -11752,7 +11800,7 @@
                           <a:ea typeface="PF Centro Sans Pro"/>
                           <a:cs typeface="PF Centro Sans Pro"/>
                         </a:rPr>
-                        <a:t>Сильная сторона</a:t>
+                        <a:t>Преимущество</a:t>
                       </a:r>
                     </a:p>
                   </a:txBody>
@@ -11832,7 +11880,7 @@
                           <a:ea typeface="PF Centro Sans Pro"/>
                           <a:cs typeface="PF Centro Sans Pro"/>
                         </a:rPr>
-                        <a:t>Человек понимает контекст</a:t>
+                        <a:t>Экспертная оценка контекста</a:t>
                       </a:r>
                     </a:p>
                   </a:txBody>
@@ -11858,7 +11906,7 @@
                           <a:ea typeface="PF Centro Sans Pro"/>
                           <a:cs typeface="PF Centro Sans Pro"/>
                         </a:rPr>
-                        <a:t>Нельзя непрерывно видеть все камеры</a:t>
+                        <a:t>Ограниченный охват наблюдения</a:t>
                       </a:r>
                     </a:p>
                   </a:txBody>
@@ -11886,7 +11934,7 @@
                           <a:ea typeface="PF Centro Sans Pro"/>
                           <a:cs typeface="PF Centro Sans Pro"/>
                         </a:rPr>
-                        <a:t>Обычная запись видеонаблюдения</a:t>
+                        <a:t>Архив видеонаблюдения</a:t>
                       </a:r>
                     </a:p>
                   </a:txBody>
@@ -11912,7 +11960,7 @@
                           <a:ea typeface="PF Centro Sans Pro"/>
                           <a:cs typeface="PF Centro Sans Pro"/>
                         </a:rPr>
-                        <a:t>Сохраняет материал для разбора</a:t>
+                        <a:t>Документирование событий</a:t>
                       </a:r>
                     </a:p>
                   </a:txBody>
@@ -11938,7 +11986,7 @@
                           <a:ea typeface="PF Centro Sans Pro"/>
                           <a:cs typeface="PF Centro Sans Pro"/>
                         </a:rPr>
-                        <a:t>Требует поиска нужного эпизода</a:t>
+                        <a:t>Ручной поиск значимых эпизодов</a:t>
                       </a:r>
                     </a:p>
                   </a:txBody>
@@ -11992,7 +12040,7 @@
                           <a:ea typeface="PF Centro Sans Pro"/>
                           <a:cs typeface="PF Centro Sans Pro"/>
                         </a:rPr>
-                        <a:t>Работают вне видимости камер</a:t>
+                        <a:t>Контроль вне поля зрения камер</a:t>
                       </a:r>
                     </a:p>
                   </a:txBody>
@@ -12018,7 +12066,7 @@
                           <a:ea typeface="PF Centro Sans Pro"/>
                           <a:cs typeface="PF Centro Sans Pro"/>
                         </a:rPr>
-                        <a:t>Нужно выдавать и обслуживать устройства</a:t>
+                        <a:t>Выдача и обслуживание устройств</a:t>
                       </a:r>
                     </a:p>
                   </a:txBody>
@@ -12072,7 +12120,7 @@
                           <a:ea typeface="PF Centro Sans Pro"/>
                           <a:cs typeface="PF Centro Sans Pro"/>
                         </a:rPr>
-                        <a:t>Автоматически выделяет события</a:t>
+                        <a:t>Автоматическое выделение событий</a:t>
                       </a:r>
                     </a:p>
                   </a:txBody>
@@ -12098,7 +12146,7 @@
                           <a:ea typeface="PF Centro Sans Pro"/>
                           <a:cs typeface="PF Centro Sans Pro"/>
                         </a:rPr>
-                        <a:t>Зависит от ракурса, света и качества моделей</a:t>
+                        <a:t>Зависимость от условий съёмки и моделей</a:t>
                       </a:r>
                     </a:p>
                   </a:txBody>
@@ -12118,7 +12166,7 @@
           <p:cNvPr id="13" name="">
             <a:extLst xmlns:a="http://schemas.openxmlformats.org/drawingml/2006/main">
               <a:ext uri="{FF2B5EF4-FFF2-40B4-BE49-F238E27FC236}">
-                <a16:creationId xmlns:a16="http://schemas.microsoft.com/office/drawing/2014/main" id="{7A064057-FACE-4E44-91B4-DEFAB2040BB6}"/>
+                <a16:creationId xmlns:a16="http://schemas.microsoft.com/office/drawing/2014/main" id="{9160C601-A144-4CF2-8364-A430FB9BD787}"/>
               </a:ext>
             </a:extLst>
           </p:cNvPr>
@@ -12165,7 +12213,7 @@
                 <a:ea typeface="PF Centro Sans Pro"/>
                 <a:cs typeface="PF Centro Sans Pro"/>
               </a:rPr>
-              <a:t>Гипотеза эффекта: меньше времени на просмотр повторов и поиск эпизодов.</a:t>
+              <a:t>Ожидаемый эффект: сокращение трудозатрат на поиск и анализ видеоэпизодов.</a:t>
             </a:r>
           </a:p>
           <a:p xmlns:a="http://schemas.openxmlformats.org/drawingml/2006/main">
@@ -12188,7 +12236,7 @@
                 <a:ea typeface="PF Centro Sans Pro"/>
                 <a:cs typeface="PF Centro Sans Pro"/>
               </a:rPr>
-              <a:t>Размер экономии и влияние на безопасность измеряются на пилоте.</a:t>
+              <a:t>Экономический эффект и влияние на безопасность подлежат оценке при апробации.</a:t>
             </a:r>
           </a:p>
         </p:txBody>
@@ -12423,7 +12471,7 @@
                 <a:ea typeface="PF Centro Sans Pro"/>
                 <a:cs typeface="PF Centro Sans Pro"/>
               </a:rPr>
-              <a:t>Контроль зон и журнал нарушений</a:t>
+              <a:t>Контроль зон и регистрация инцидентов</a:t>
             </a:r>
             <a:endParaRPr sz="1200">
               <a:latin typeface="Aptos"/>
@@ -12465,7 +12513,7 @@
                 <a:ea typeface="PF Centro Sans Pro"/>
                 <a:cs typeface="PF Centro Sans Pro"/>
               </a:rPr>
-              <a:t>Полигональные зоны, треки людей, временная фильтрация событий, статусы и комментарии оператора, CSV-отчёты.</a:t>
+              <a:t>Полигональное геозонирование, сопровождение объектов, временная фильтрация событий, обработка инцидентов и экспорт отчётов.</a:t>
             </a:r>
             <a:endParaRPr sz="1600">
               <a:latin typeface="PF Centro Sans Pro"/>
@@ -12507,7 +12555,7 @@
                 <a:ea typeface="PF Centro Sans Pro"/>
                 <a:cs typeface="PF Centro Sans Pro"/>
               </a:rPr>
-              <a:t>Архитектура поддерживает каскад: человек, СИЗ по crop, поза, временной классификатор поведения.</a:t>
+              <a:t>Предусмотрено расширение: анализ СИЗ в области объекта, оценка позы и временная классификация поведения.</a:t>
             </a:r>
           </a:p>
         </p:txBody>
@@ -12521,7 +12569,7 @@
           <p:nvPr/>
         </p:nvPicPr>
         <p:blipFill>
-          <a:blip xmlns:r="http://schemas.openxmlformats.org/officeDocument/2006/relationships" xmlns:a="http://schemas.openxmlformats.org/drawingml/2006/main" r:embed="R3b401b11e147456f"/>
+          <a:blip xmlns:r="http://schemas.openxmlformats.org/officeDocument/2006/relationships" xmlns:a="http://schemas.openxmlformats.org/drawingml/2006/main" r:embed="R48c42037468b4f01"/>
           <a:stretch xmlns:a="http://schemas.openxmlformats.org/drawingml/2006/main">
             <a:fillRect l="0" t="0" r="0" b="0"/>
           </a:stretch>
@@ -12545,7 +12593,7 @@
           <p:nvPr/>
         </p:nvPicPr>
         <p:blipFill>
-          <a:blip xmlns:r="http://schemas.openxmlformats.org/officeDocument/2006/relationships" xmlns:a="http://schemas.openxmlformats.org/drawingml/2006/main" r:embed="Re25f4c1256934810"/>
+          <a:blip xmlns:r="http://schemas.openxmlformats.org/officeDocument/2006/relationships" xmlns:a="http://schemas.openxmlformats.org/drawingml/2006/main" r:embed="Rd1b4047f6d864132"/>
           <a:stretch xmlns:a="http://schemas.openxmlformats.org/drawingml/2006/main"/>
         </p:blipFill>
         <p:spPr>
@@ -12563,7 +12611,7 @@
           <p:cNvPr id="13" name="">
             <a:extLst xmlns:a="http://schemas.openxmlformats.org/drawingml/2006/main">
               <a:ext uri="{FF2B5EF4-FFF2-40B4-BE49-F238E27FC236}">
-                <a16:creationId xmlns:a16="http://schemas.microsoft.com/office/drawing/2014/main" id="{A3F923FC-AD57-47CC-8B6F-7A65D4FB8F04}"/>
+                <a16:creationId xmlns:a16="http://schemas.microsoft.com/office/drawing/2014/main" id="{92A0D504-EB23-4401-89AC-C45092888C0C}"/>
               </a:ext>
             </a:extLst>
           </p:cNvPr>
@@ -12620,7 +12668,7 @@
           <p:cNvPr id="14" name="">
             <a:extLst xmlns:a="http://schemas.openxmlformats.org/drawingml/2006/main">
               <a:ext uri="{FF2B5EF4-FFF2-40B4-BE49-F238E27FC236}">
-                <a16:creationId xmlns:a16="http://schemas.microsoft.com/office/drawing/2014/main" id="{7B269D71-EEB1-4A8B-AC67-851C48EF2ADE}"/>
+                <a16:creationId xmlns:a16="http://schemas.microsoft.com/office/drawing/2014/main" id="{9368622C-D78B-4FC1-B67A-9E16045E1795}"/>
               </a:ext>
             </a:extLst>
           </p:cNvPr>
@@ -12667,7 +12715,7 @@
                 <a:ea typeface="PF Centro Sans Pro"/>
                 <a:cs typeface="PF Centro Sans Pro"/>
               </a:rPr>
-              <a:t>Детектор людей YOLO11n подключён. Модели СИЗ и поведения пока не установлены.</a:t>
+              <a:t>Интегрирован детектор людей YOLO11n. Модели СИЗ и поведения не установлены.</a:t>
             </a:r>
           </a:p>
           <a:p xmlns:a="http://schemas.openxmlformats.org/drawingml/2006/main">
@@ -12690,7 +12738,7 @@
                 <a:ea typeface="PF Centro Sans Pro"/>
                 <a:cs typeface="PF Centro Sans Pro"/>
               </a:rPr>
-              <a:t>Ценность для проверки на пилоте: меньше повторных тревог и быстрее разбор одного эпизода.</a:t>
+              <a:t>Проверяемая гипотеза: снижение числа повторных тревог и времени обработки инцидента.</a:t>
             </a:r>
           </a:p>
         </p:txBody>
@@ -12923,7 +12971,7 @@
                 <a:ea typeface="PF Centro Sans Pro"/>
                 <a:cs typeface="PF Centro Sans Pro"/>
               </a:rPr>
-              <a:t>Целевые заказчики: промышленные предприятия с IP-камерами. Пользователи: служба охраны труда и диспетчер. Решение о пилоте принимается совместно с ИТ и ИБ.</a:t>
+              <a:t>Целевой сегмент: промышленные предприятия с IP-видеонаблюдением. Пользователи: служба охраны труда и диспетчерский персонал. Апробация согласуется с подразделениями ИТ и ИБ.</a:t>
             </a:r>
           </a:p>
         </p:txBody>
@@ -12981,7 +13029,7 @@
           <p:nvPr/>
         </p:nvPicPr>
         <p:blipFill>
-          <a:blip xmlns:r="http://schemas.openxmlformats.org/officeDocument/2006/relationships" xmlns:a="http://schemas.openxmlformats.org/drawingml/2006/main" r:embed="Rc7a1470ea46f4a67"/>
+          <a:blip xmlns:r="http://schemas.openxmlformats.org/officeDocument/2006/relationships" xmlns:a="http://schemas.openxmlformats.org/drawingml/2006/main" r:embed="R4577912602ab4c50"/>
           <a:stretch xmlns:a="http://schemas.openxmlformats.org/drawingml/2006/main">
             <a:fillRect l="0" t="0" r="0" b="0"/>
           </a:stretch>
@@ -13058,7 +13106,7 @@
                           <a:ea typeface="PF Centro Sans Pro"/>
                           <a:cs typeface="PF Centro Sans Pro"/>
                         </a:rPr>
-                        <a:t>Что предлагает поставщик</a:t>
+                        <a:t>Заявленные возможности</a:t>
                       </a:r>
                     </a:p>
                   </a:txBody>
@@ -13084,7 +13132,7 @@
                           <a:ea typeface="PF Centro Sans Pro"/>
                           <a:cs typeface="PF Centro Sans Pro"/>
                         </a:rPr>
-                        <a:t>Что проверить при сравнении</a:t>
+                        <a:t>Параметры сопоставления</a:t>
                       </a:r>
                     </a:p>
                   </a:txBody>
@@ -13344,7 +13392,7 @@
           <p:cNvPr id="13" name="">
             <a:extLst xmlns:a="http://schemas.openxmlformats.org/drawingml/2006/main">
               <a:ext uri="{FF2B5EF4-FFF2-40B4-BE49-F238E27FC236}">
-                <a16:creationId xmlns:a16="http://schemas.microsoft.com/office/drawing/2014/main" id="{E04DFA0F-03EF-4929-9390-90C2079873CF}"/>
+                <a16:creationId xmlns:a16="http://schemas.microsoft.com/office/drawing/2014/main" id="{035C8838-362F-42D5-935B-E526F356D417}"/>
               </a:ext>
             </a:extLst>
           </p:cNvPr>
@@ -13391,7 +13439,7 @@
                 <a:ea typeface="PF Centro Sans Pro"/>
                 <a:cs typeface="PF Centro Sans Pro"/>
               </a:rPr>
-              <a:t>Цены аналогов: сопоставимые коммерческие предложения не получены.</a:t>
+              <a:t>Сопоставимые коммерческие предложения не получены.</a:t>
             </a:r>
           </a:p>
           <a:p xmlns:a="http://schemas.openxmlformats.org/drawingml/2006/main">
@@ -13414,7 +13462,7 @@
                 <a:ea typeface="PF Centro Sans Pro"/>
                 <a:cs typeface="PF Centro Sans Pro"/>
               </a:rPr>
-              <a:t>Преимущество HSE AI-Video по цене и точности пока не доказано.</a:t>
+              <a:t>Преимущества по стоимости и качеству распознавания требуют сравнительных испытаний.</a:t>
             </a:r>
           </a:p>
         </p:txBody>
@@ -13424,7 +13472,7 @@
           <p:cNvPr id="14" name="">
             <a:extLst xmlns:a="http://schemas.openxmlformats.org/drawingml/2006/main">
               <a:ext uri="{FF2B5EF4-FFF2-40B4-BE49-F238E27FC236}">
-                <a16:creationId xmlns:a16="http://schemas.microsoft.com/office/drawing/2014/main" id="{EBBFF270-87DD-4224-93F0-3D99D60265B1}"/>
+                <a16:creationId xmlns:a16="http://schemas.microsoft.com/office/drawing/2014/main" id="{0D41FE38-77D0-467B-9765-FE82A176BED4}"/>
               </a:ext>
             </a:extLst>
           </p:cNvPr>
@@ -13494,7 +13542,7 @@
                 <a:ea typeface="PF Centro Sans Pro"/>
                 <a:cs typeface="PF Centro Sans Pro"/>
               </a:rPr>
-              <a:t>Размер и темп роста рынка не оценены. На следующем этапе: интервью и запросы цен.</a:t>
+              <a:t>Объём рынка не оценён. План исследования: интервью заказчиков и анализ коммерческих предложений.</a:t>
             </a:r>
           </a:p>
         </p:txBody>
@@ -13729,7 +13777,7 @@
                 <a:ea typeface="PF Centro Sans Pro"/>
                 <a:cs typeface="PF Centro Sans Pro"/>
               </a:rPr>
-              <a:t>Модель продаж: локальная лицензия, внедрение и ежегодная поддержка.</a:t>
+              <a:t>Модель коммерциализации: локальная лицензия, внедрение и ежегодная поддержка.</a:t>
             </a:r>
           </a:p>
           <a:p xmlns:a="http://schemas.openxmlformats.org/drawingml/2006/main">
@@ -13772,7 +13820,7 @@
           <p:nvPr/>
         </p:nvPicPr>
         <p:blipFill>
-          <a:blip xmlns:r="http://schemas.openxmlformats.org/officeDocument/2006/relationships" xmlns:a="http://schemas.openxmlformats.org/drawingml/2006/main" r:embed="R471c226104fa4ade"/>
+          <a:blip xmlns:r="http://schemas.openxmlformats.org/officeDocument/2006/relationships" xmlns:a="http://schemas.openxmlformats.org/drawingml/2006/main" r:embed="R0cf9c68bfb2840c3"/>
           <a:stretch xmlns:a="http://schemas.openxmlformats.org/drawingml/2006/main">
             <a:fillRect l="0" t="0" r="0" b="0"/>
           </a:stretch>
@@ -14240,7 +14288,7 @@
           <p:cNvPr id="13" name="">
             <a:extLst xmlns:a="http://schemas.openxmlformats.org/drawingml/2006/main">
               <a:ext uri="{FF2B5EF4-FFF2-40B4-BE49-F238E27FC236}">
-                <a16:creationId xmlns:a16="http://schemas.microsoft.com/office/drawing/2014/main" id="{C840224D-4009-45CD-9F35-4314D2D12397}"/>
+                <a16:creationId xmlns:a16="http://schemas.microsoft.com/office/drawing/2014/main" id="{B161759B-91E5-4247-9E4C-6525CEC9044B}"/>
               </a:ext>
             </a:extLst>
           </p:cNvPr>
@@ -14287,7 +14335,7 @@
                 <a:ea typeface="PF Centro Sans Pro"/>
                 <a:cs typeface="PF Centro Sans Pro"/>
               </a:rPr>
-              <a:t>Основание: плановая пропускная способность небольшой команды, а не подтверждённые предзаказы. Интервью, письма интереса и воронку продаж нужно собрать.</a:t>
+              <a:t>Прогноз основан на плановой загрузке команды. Предзаказы отсутствуют. Для верификации спроса предусмотрены интервью заказчиков и сбор писем о заинтересованности.</a:t>
             </a:r>
           </a:p>
         </p:txBody>
@@ -14297,7 +14345,7 @@
           <p:cNvPr id="14" name="">
             <a:extLst xmlns:a="http://schemas.openxmlformats.org/drawingml/2006/main">
               <a:ext uri="{FF2B5EF4-FFF2-40B4-BE49-F238E27FC236}">
-                <a16:creationId xmlns:a16="http://schemas.microsoft.com/office/drawing/2014/main" id="{07318FF6-6CB1-48F5-9E96-EE567F6CB3A4}"/>
+                <a16:creationId xmlns:a16="http://schemas.microsoft.com/office/drawing/2014/main" id="{AF3887E1-806A-441C-92A2-1541C730966C}"/>
               </a:ext>
             </a:extLst>
           </p:cNvPr>
@@ -14344,7 +14392,7 @@
                 <a:ea typeface="PF Centro Sans Pro"/>
                 <a:cs typeface="PF Centro Sans Pro"/>
               </a:rPr>
-              <a:t>Целевой масштаб 200 площадок при условной цене 480 тыс. руб. даёт 96 млн руб. разовых продаж. Это сценарий расширения, не размер рынка и не текущая доля.</a:t>
+              <a:t>При расширении до 200 площадок и цене 480 тыс. руб. расчётный объём разовых продаж составит 96 млн руб. Показатель характеризует сценарий масштабирования, а не ёмкость рынка.</a:t>
             </a:r>
           </a:p>
         </p:txBody>
@@ -14579,7 +14627,7 @@
                 <a:ea typeface="PF Centro Sans Pro"/>
                 <a:cs typeface="PF Centro Sans Pro"/>
               </a:rPr>
-              <a:t>Реализованная цепочка прототипа</a:t>
+              <a:t>Архитектура программного прототипа</a:t>
             </a:r>
             <a:endParaRPr sz="1200">
               <a:latin typeface="Aptos"/>
@@ -14598,7 +14646,7 @@
           <p:nvPr/>
         </p:nvPicPr>
         <p:blipFill>
-          <a:blip xmlns:r="http://schemas.openxmlformats.org/officeDocument/2006/relationships" xmlns:a="http://schemas.openxmlformats.org/drawingml/2006/main" r:embed="R8203982bad9541fc"/>
+          <a:blip xmlns:r="http://schemas.openxmlformats.org/officeDocument/2006/relationships" xmlns:a="http://schemas.openxmlformats.org/drawingml/2006/main" r:embed="Ra0e17d4c60334ac9"/>
           <a:stretch xmlns:a="http://schemas.openxmlformats.org/drawingml/2006/main">
             <a:fillRect l="0" t="0" r="0" b="0"/>
           </a:stretch>
@@ -14618,7 +14666,7 @@
           <p:cNvPr id="12" name="">
             <a:extLst xmlns:a="http://schemas.openxmlformats.org/drawingml/2006/main">
               <a:ext uri="{FF2B5EF4-FFF2-40B4-BE49-F238E27FC236}">
-                <a16:creationId xmlns:a16="http://schemas.microsoft.com/office/drawing/2014/main" id="{D01DFE84-7268-4F9F-AD94-8A866B59978F}"/>
+                <a16:creationId xmlns:a16="http://schemas.microsoft.com/office/drawing/2014/main" id="{B0E9D636-63C5-4946-A96F-A879BBC24A27}"/>
               </a:ext>
             </a:extLst>
           </p:cNvPr>
@@ -14702,7 +14750,7 @@
           <p:cNvPr id="13" name="">
             <a:extLst xmlns:a="http://schemas.openxmlformats.org/drawingml/2006/main">
               <a:ext uri="{FF2B5EF4-FFF2-40B4-BE49-F238E27FC236}">
-                <a16:creationId xmlns:a16="http://schemas.microsoft.com/office/drawing/2014/main" id="{0C52A9DC-0D21-4825-9AC2-A9FF9E2FA3DA}"/>
+                <a16:creationId xmlns:a16="http://schemas.microsoft.com/office/drawing/2014/main" id="{343F5DAF-031A-46DA-A9E3-64D4F044E378}"/>
               </a:ext>
             </a:extLst>
           </p:cNvPr>
@@ -14732,7 +14780,7 @@
           <p:cNvPr id="14" name="">
             <a:extLst xmlns:a="http://schemas.openxmlformats.org/drawingml/2006/main">
               <a:ext uri="{FF2B5EF4-FFF2-40B4-BE49-F238E27FC236}">
-                <a16:creationId xmlns:a16="http://schemas.microsoft.com/office/drawing/2014/main" id="{72C9E18B-33B2-4F35-B5C7-BA3A47366CA3}"/>
+                <a16:creationId xmlns:a16="http://schemas.microsoft.com/office/drawing/2014/main" id="{4A95A28C-45FA-4885-9C72-C578975DFF50}"/>
               </a:ext>
             </a:extLst>
           </p:cNvPr>
@@ -14783,7 +14831,7 @@
                 <a:ea typeface="PF Centro Sans Pro"/>
                 <a:cs typeface="PF Centro Sans Pro"/>
               </a:rPr>
-              <a:t>Инжестирование</a:t>
+              <a:t>Приём видео</a:t>
             </a:r>
           </a:p>
           <a:p xmlns:a="http://schemas.openxmlformats.org/drawingml/2006/main">
@@ -14806,7 +14854,7 @@
                 <a:ea typeface="PF Centro Sans Pro"/>
                 <a:cs typeface="PF Centro Sans Pro"/>
               </a:rPr>
-              <a:t>PyAV, свежий кадр</a:t>
+              <a:t>PyAV, буфер кадров</a:t>
             </a:r>
           </a:p>
         </p:txBody>
@@ -14816,7 +14864,7 @@
           <p:cNvPr id="15" name="">
             <a:extLst xmlns:a="http://schemas.openxmlformats.org/drawingml/2006/main">
               <a:ext uri="{FF2B5EF4-FFF2-40B4-BE49-F238E27FC236}">
-                <a16:creationId xmlns:a16="http://schemas.microsoft.com/office/drawing/2014/main" id="{DB168D5C-15E8-42B9-A600-2F0374DFEA5F}"/>
+                <a16:creationId xmlns:a16="http://schemas.microsoft.com/office/drawing/2014/main" id="{15E04B76-0158-411B-AB01-B91A72EE5501}"/>
               </a:ext>
             </a:extLst>
           </p:cNvPr>
@@ -14846,7 +14894,7 @@
           <p:cNvPr id="16" name="">
             <a:extLst xmlns:a="http://schemas.openxmlformats.org/drawingml/2006/main">
               <a:ext uri="{FF2B5EF4-FFF2-40B4-BE49-F238E27FC236}">
-                <a16:creationId xmlns:a16="http://schemas.microsoft.com/office/drawing/2014/main" id="{DA5E820C-1BF4-462F-AAB6-131AE6E70164}"/>
+                <a16:creationId xmlns:a16="http://schemas.microsoft.com/office/drawing/2014/main" id="{EEFE14AB-E54A-4C43-B404-48EFF687E8A8}"/>
               </a:ext>
             </a:extLst>
           </p:cNvPr>
@@ -14897,7 +14945,7 @@
                 <a:ea typeface="PF Centro Sans Pro"/>
                 <a:cs typeface="PF Centro Sans Pro"/>
               </a:rPr>
-              <a:t>AI-сервис</a:t>
+              <a:t>Инференс</a:t>
             </a:r>
           </a:p>
           <a:p xmlns:a="http://schemas.openxmlformats.org/drawingml/2006/main">
@@ -14930,7 +14978,7 @@
           <p:cNvPr id="17" name="">
             <a:extLst xmlns:a="http://schemas.openxmlformats.org/drawingml/2006/main">
               <a:ext uri="{FF2B5EF4-FFF2-40B4-BE49-F238E27FC236}">
-                <a16:creationId xmlns:a16="http://schemas.microsoft.com/office/drawing/2014/main" id="{2CD477AC-6219-42F6-94F3-940A5C3FDE44}"/>
+                <a16:creationId xmlns:a16="http://schemas.microsoft.com/office/drawing/2014/main" id="{3FE391D1-82D8-48E0-9411-34A04A4031FD}"/>
               </a:ext>
             </a:extLst>
           </p:cNvPr>
@@ -14960,7 +15008,7 @@
           <p:cNvPr id="18" name="">
             <a:extLst xmlns:a="http://schemas.openxmlformats.org/drawingml/2006/main">
               <a:ext uri="{FF2B5EF4-FFF2-40B4-BE49-F238E27FC236}">
-                <a16:creationId xmlns:a16="http://schemas.microsoft.com/office/drawing/2014/main" id="{1E80C441-4BCE-4A0F-9405-DAC43E7E3C04}"/>
+                <a16:creationId xmlns:a16="http://schemas.microsoft.com/office/drawing/2014/main" id="{2F4DE1C1-5112-4479-8F12-FB35ED342533}"/>
               </a:ext>
             </a:extLst>
           </p:cNvPr>
@@ -15044,7 +15092,7 @@
           <p:cNvPr id="19" name="">
             <a:extLst xmlns:a="http://schemas.openxmlformats.org/drawingml/2006/main">
               <a:ext uri="{FF2B5EF4-FFF2-40B4-BE49-F238E27FC236}">
-                <a16:creationId xmlns:a16="http://schemas.microsoft.com/office/drawing/2014/main" id="{4393543C-0F6B-4170-85C6-961A3EEC9D33}"/>
+                <a16:creationId xmlns:a16="http://schemas.microsoft.com/office/drawing/2014/main" id="{EF7B0ECF-2DBE-4B51-B093-2CAD6776A549}"/>
               </a:ext>
             </a:extLst>
           </p:cNvPr>
@@ -15074,7 +15122,7 @@
           <p:cNvPr id="20" name="">
             <a:extLst xmlns:a="http://schemas.openxmlformats.org/drawingml/2006/main">
               <a:ext uri="{FF2B5EF4-FFF2-40B4-BE49-F238E27FC236}">
-                <a16:creationId xmlns:a16="http://schemas.microsoft.com/office/drawing/2014/main" id="{F8307EE6-8089-409D-8498-83A1F6F920CD}"/>
+                <a16:creationId xmlns:a16="http://schemas.microsoft.com/office/drawing/2014/main" id="{8BECC99F-01B6-4135-B46A-8185AD218755}"/>
               </a:ext>
             </a:extLst>
           </p:cNvPr>
@@ -15158,7 +15206,7 @@
           <p:cNvPr id="21" name="">
             <a:extLst xmlns:a="http://schemas.openxmlformats.org/drawingml/2006/main">
               <a:ext uri="{FF2B5EF4-FFF2-40B4-BE49-F238E27FC236}">
-                <a16:creationId xmlns:a16="http://schemas.microsoft.com/office/drawing/2014/main" id="{5813623D-60CA-454E-94BE-C6F27D43C767}"/>
+                <a16:creationId xmlns:a16="http://schemas.microsoft.com/office/drawing/2014/main" id="{5B6B7BE3-0902-4667-86C3-89752F6C8C5E}"/>
               </a:ext>
             </a:extLst>
           </p:cNvPr>
@@ -15205,7 +15253,7 @@
                 <a:ea typeface="PF Centro Sans Pro"/>
                 <a:cs typeface="PF Centro Sans Pro"/>
               </a:rPr>
-              <a:t>Доставка: HTTP между сервисами, WebSocket в браузер. PostgreSQL, Redis и S3 предусмотрены в Compose. Локальная демонстрация использует SQLite.</a:t>
+              <a:t>Межсервисный обмен: HTTP; передача в браузер: WebSocket. Конфигурация Compose предусматривает PostgreSQL, Redis и S3. В локальном режиме используется SQLite.</a:t>
             </a:r>
           </a:p>
         </p:txBody>
@@ -15215,7 +15263,7 @@
           <p:cNvPr id="22" name="">
             <a:extLst xmlns:a="http://schemas.openxmlformats.org/drawingml/2006/main">
               <a:ext uri="{FF2B5EF4-FFF2-40B4-BE49-F238E27FC236}">
-                <a16:creationId xmlns:a16="http://schemas.microsoft.com/office/drawing/2014/main" id="{4C5A82E0-DEFD-4543-9676-F594B67647EE}"/>
+                <a16:creationId xmlns:a16="http://schemas.microsoft.com/office/drawing/2014/main" id="{0969309B-A26C-490F-8ADC-8E2CD15BFD29}"/>
               </a:ext>
             </a:extLst>
           </p:cNvPr>
@@ -15262,7 +15310,7 @@
                 <a:ea typeface="PF Centro Sans Pro"/>
                 <a:cs typeface="PF Centro Sans Pro"/>
               </a:rPr>
-              <a:t>Пилот: существующие камеры и локальная сеть, сервер по результатам замера нагрузки. Оценочный бюджет тестового сервера: 300 тыс. руб. Поставщик и конфигурация пока не выбраны.</a:t>
+              <a:t>Инфраструктура апробации: существующие камеры и локальная сеть. Сервер выбирается по результатам нагрузочных испытаний. Предварительный бюджет: 300 тыс. руб.; конфигурация не определена.</a:t>
             </a:r>
           </a:p>
         </p:txBody>
@@ -15272,7 +15320,7 @@
           <p:cNvPr id="23" name="">
             <a:extLst xmlns:a="http://schemas.openxmlformats.org/drawingml/2006/main">
               <a:ext uri="{FF2B5EF4-FFF2-40B4-BE49-F238E27FC236}">
-                <a16:creationId xmlns:a16="http://schemas.microsoft.com/office/drawing/2014/main" id="{8B3317F7-94D0-49EC-84D6-3AD54368B4A0}"/>
+                <a16:creationId xmlns:a16="http://schemas.microsoft.com/office/drawing/2014/main" id="{5AB4EA15-10C5-4353-A7B6-AD494212AC02}"/>
               </a:ext>
             </a:extLst>
           </p:cNvPr>
@@ -15319,7 +15367,7 @@
                 <a:ea typeface="PF Centro Sans Pro"/>
                 <a:cs typeface="PF Centro Sans Pro"/>
               </a:rPr>
-              <a:t>Triton, OpenVINO и gRPC: возможное развитие. Их производительность не заявляется.</a:t>
+              <a:t>Triton, OpenVINO и gRPC рассматриваются для последующего развития.</a:t>
             </a:r>
           </a:p>
           <a:p xmlns:a="http://schemas.openxmlformats.org/drawingml/2006/main">
@@ -15342,7 +15390,7 @@
                 <a:ea typeface="PF Centro Sans Pro"/>
                 <a:cs typeface="PF Centro Sans Pro"/>
               </a:rPr>
-              <a:t>Сборка для закрытого контура требует переноса образов и проверки лицензий моделей.</a:t>
+              <a:t>Развёртывание в закрытом контуре требует переноса образов и проверки лицензий моделей.</a:t>
             </a:r>
           </a:p>
         </p:txBody>
@@ -15544,7 +15592,7 @@
         <p:spPr>
           <a:xfrm xmlns:a="http://schemas.openxmlformats.org/drawingml/2006/main">
             <a:off x="762000" y="523875"/>
-            <a:ext cx="10668000" cy="809625"/>
+            <a:ext cx="10668000" cy="982980"/>
           </a:xfrm>
           <a:prstGeom xmlns:a="http://schemas.openxmlformats.org/drawingml/2006/main" prst="rect">
             <a:avLst/>
@@ -15577,7 +15625,7 @@
                 <a:ea typeface="PF Centro Sans Pro"/>
                 <a:cs typeface="PF Centro Sans Pro"/>
               </a:rPr>
-              <a:t>Текущий инициатор: Павлов Иван Владимирович.</a:t>
+              <a:t>Команда: Павлов Иван Владимирович — инициатор; Фролов Денис — разработчик программной платформы.</a:t>
             </a:r>
           </a:p>
           <a:p xmlns:a="http://schemas.openxmlformats.org/drawingml/2006/main">
@@ -15601,7 +15649,7 @@
                 <a:ea typeface="PF Centro Sans Pro"/>
                 <a:cs typeface="PF Centro Sans Pro"/>
               </a:rPr>
-              <a:t>Для трёхмесячного этапа подготовки пилота предлагается привлечь специалистов.</a:t>
+              <a:t>Ресурсный план подготовки к апробации рассчитан на 3 месяца.</a:t>
             </a:r>
           </a:p>
         </p:txBody>
@@ -15615,7 +15663,7 @@
           <p:nvPr/>
         </p:nvPicPr>
         <p:blipFill>
-          <a:blip xmlns:r="http://schemas.openxmlformats.org/officeDocument/2006/relationships" xmlns:a="http://schemas.openxmlformats.org/drawingml/2006/main" r:embed="R7879cc87f7fe4190"/>
+          <a:blip xmlns:r="http://schemas.openxmlformats.org/officeDocument/2006/relationships" xmlns:a="http://schemas.openxmlformats.org/drawingml/2006/main" r:embed="R5fbe61280d1c49ff"/>
           <a:stretch xmlns:a="http://schemas.openxmlformats.org/drawingml/2006/main">
             <a:fillRect l="0" t="0" r="0" b="0"/>
           </a:stretch>
@@ -15666,7 +15714,7 @@
                           <a:ea typeface="PF Centro Sans Pro"/>
                           <a:cs typeface="PF Centro Sans Pro"/>
                         </a:rPr>
-                        <a:t>Роль, план привлечения</a:t>
+                        <a:t>Направление работ</a:t>
                       </a:r>
                     </a:p>
                   </a:txBody>
@@ -15986,7 +16034,7 @@
                           <a:ea typeface="PF Centro Sans Pro"/>
                           <a:cs typeface="PF Centro Sans Pro"/>
                         </a:rPr>
-                        <a:t>Итого работы команды</a:t>
+                        <a:t>Итого стоимость работ</a:t>
                       </a:r>
                     </a:p>
                   </a:txBody>
@@ -16012,7 +16060,7 @@
                           <a:ea typeface="PF Centro Sans Pro"/>
                           <a:cs typeface="PF Centro Sans Pro"/>
                         </a:rPr>
-                        <a:t>Состав и договоры предстоит определить</a:t>
+                        <a:t>Загрузка и условия требуют уточнения</a:t>
                       </a:r>
                     </a:p>
                   </a:txBody>
@@ -16058,7 +16106,7 @@
           <p:cNvPr id="13" name="">
             <a:extLst xmlns:a="http://schemas.openxmlformats.org/drawingml/2006/main">
               <a:ext uri="{FF2B5EF4-FFF2-40B4-BE49-F238E27FC236}">
-                <a16:creationId xmlns:a16="http://schemas.microsoft.com/office/drawing/2014/main" id="{6FD38FDF-D455-4498-A494-AD45E6532DF3}"/>
+                <a16:creationId xmlns:a16="http://schemas.microsoft.com/office/drawing/2014/main" id="{756791E9-8E83-464C-8183-E2C2AC3260DE}"/>
               </a:ext>
             </a:extLst>
           </p:cNvPr>
@@ -16105,7 +16153,7 @@
                 <a:ea typeface="PF Centro Sans Pro"/>
                 <a:cs typeface="PF Centro Sans Pro"/>
               </a:rPr>
-              <a:t>Оценка стоимости работ с сопутствующими выплатами, не действующий ФОТ.</a:t>
+              <a:t>Плановая стоимость работ с сопутствующими выплатами; действующий ФОТ не сформирован.</a:t>
             </a:r>
           </a:p>
           <a:p xmlns:a="http://schemas.openxmlformats.org/drawingml/2006/main">
@@ -16128,7 +16176,7 @@
                 <a:ea typeface="PF Centro Sans Pro"/>
                 <a:cs typeface="PF Centro Sans Pro"/>
               </a:rPr>
-              <a:t>Эксперт заказчика участвует в согласовании зон, правил и реакции на события.</a:t>
+              <a:t>Предусмотрено участие эксперта заказчика в согласовании зон и регламентов реагирования.</a:t>
             </a:r>
           </a:p>
         </p:txBody>
@@ -16160,7 +16208,7 @@
           <p:cNvPr id="6" name="Rectangle 5">
             <a:extLst xmlns:a="http://schemas.openxmlformats.org/drawingml/2006/main">
               <a:ext uri="{FF2B5EF4-FFF2-40B4-BE49-F238E27FC236}">
-                <a16:creationId xmlns:a16="http://schemas.microsoft.com/office/drawing/2014/main" id="{24D0ECBE-C695-4525-B13C-46F0B0BA0DD4}"/>
+                <a16:creationId xmlns:a16="http://schemas.microsoft.com/office/drawing/2014/main" id="{CD26FFB9-1798-4003-BE08-A56C59B0A348}"/>
               </a:ext>
             </a:extLst>
           </p:cNvPr>
@@ -16220,7 +16268,7 @@
           <p:cNvPr id="7" name="Rectangle 6">
             <a:extLst xmlns:a="http://schemas.openxmlformats.org/drawingml/2006/main">
               <a:ext uri="{FF2B5EF4-FFF2-40B4-BE49-F238E27FC236}">
-                <a16:creationId xmlns:a16="http://schemas.microsoft.com/office/drawing/2014/main" id="{5E0C98A8-EAAA-4691-964F-54C78A930ECA}"/>
+                <a16:creationId xmlns:a16="http://schemas.microsoft.com/office/drawing/2014/main" id="{593B6C40-CC4C-4531-8AB8-27158DAE88F8}"/>
               </a:ext>
             </a:extLst>
           </p:cNvPr>
@@ -16278,7 +16326,7 @@
           <p:cNvPr id="9" name="Rectangle 8">
             <a:extLst xmlns:a="http://schemas.openxmlformats.org/drawingml/2006/main">
               <a:ext uri="{FF2B5EF4-FFF2-40B4-BE49-F238E27FC236}">
-                <a16:creationId xmlns:a16="http://schemas.microsoft.com/office/drawing/2014/main" id="{E908C388-812D-4B7A-ADC4-50255A712208}"/>
+                <a16:creationId xmlns:a16="http://schemas.microsoft.com/office/drawing/2014/main" id="{A28630F9-1D97-4902-800B-090812CBC088}"/>
               </a:ext>
             </a:extLst>
           </p:cNvPr>
@@ -16433,7 +16481,7 @@
                 <a:ea typeface="PF Centro Sans Pro"/>
                 <a:cs typeface="PF Centro Sans Pro"/>
               </a:rPr>
-              <a:t>Инициатор: физическое лицо. Форму коммерческой деятельности и права на используемые компоненты необходимо определить до начала продаж.</a:t>
+              <a:t>Заявитель: физическое лицо. До коммерциализации требуется определить организационно-правовую форму и условия использования программных компонентов.</a:t>
             </a:r>
             <a:endParaRPr sz="1600">
               <a:latin typeface="PF Centro Sans Pro"/>
@@ -16452,7 +16500,7 @@
           <p:nvPr/>
         </p:nvPicPr>
         <p:blipFill>
-          <a:blip xmlns:r="http://schemas.openxmlformats.org/officeDocument/2006/relationships" xmlns:a="http://schemas.openxmlformats.org/drawingml/2006/main" r:embed="R3c757882b18e4750"/>
+          <a:blip xmlns:r="http://schemas.openxmlformats.org/officeDocument/2006/relationships" xmlns:a="http://schemas.openxmlformats.org/drawingml/2006/main" r:embed="Raa25a71a42f94c8d"/>
           <a:stretch xmlns:a="http://schemas.openxmlformats.org/drawingml/2006/main">
             <a:fillRect l="0" t="0" r="0" b="0"/>
           </a:stretch>
@@ -16609,7 +16657,7 @@
                           <a:ea typeface="PF Centro Sans Pro"/>
                           <a:cs typeface="PF Centro Sans Pro"/>
                         </a:rPr>
-                        <a:t>Партнёр, доступ к видео, выборка и критерии приёмки</a:t>
+                        <a:t>Партнёр, видеоданные, выборка и критерии приёмки</a:t>
                       </a:r>
                     </a:p>
                   </a:txBody>
@@ -16689,7 +16737,7 @@
                           <a:ea typeface="PF Centro Sans Pro"/>
                           <a:cs typeface="PF Centro Sans Pro"/>
                         </a:rPr>
-                        <a:t>Подключённые модели, оценка на отложенной выборке</a:t>
+                        <a:t>Интеграция моделей, независимая тестовая выборка</a:t>
                       </a:r>
                     </a:p>
                   </a:txBody>
@@ -16769,7 +16817,7 @@
                           <a:ea typeface="PF Centro Sans Pro"/>
                           <a:cs typeface="PF Centro Sans Pro"/>
                         </a:rPr>
-                        <a:t>Пилот на 1–2 участках, качество и нагрузка</a:t>
+                        <a:t>Апробация на 1–2 участках, оценка качества и нагрузки</a:t>
                       </a:r>
                     </a:p>
                   </a:txBody>
@@ -16895,7 +16943,7 @@
           <p:cNvPr id="14" name="">
             <a:extLst xmlns:a="http://schemas.openxmlformats.org/drawingml/2006/main">
               <a:ext uri="{FF2B5EF4-FFF2-40B4-BE49-F238E27FC236}">
-                <a16:creationId xmlns:a16="http://schemas.microsoft.com/office/drawing/2014/main" id="{5CD0C00D-1DBC-4363-B6C5-7418D8312794}"/>
+                <a16:creationId xmlns:a16="http://schemas.microsoft.com/office/drawing/2014/main" id="{FA9608E5-637D-4F32-9D14-19E7D59B5921}"/>
               </a:ext>
             </a:extLst>
           </p:cNvPr>
@@ -16942,7 +16990,7 @@
                 <a:ea typeface="PF Centro Sans Pro"/>
                 <a:cs typeface="PF Centro Sans Pro"/>
               </a:rPr>
-              <a:t>Следующий этап: тиражирование после успешного пилота. Сроки зависят от доступа к данным, договоров и результатов испытаний.</a:t>
+              <a:t>Тиражирование предусматривается после достижения критериев приёмки. Сроки определяются доступностью данных, договорными условиями и результатами испытаний.</a:t>
             </a:r>
           </a:p>
         </p:txBody>

</xml_diff>